<commit_message>
docs: merge presentation physical model
Co-authored-by: Copilot <223556219+Copilot@users.noreply.github.com>

Copilot-Session: 3cff267c-e462-444f-8245-2ab07ec0bcd1
</commit_message>
<xml_diff>
--- a/prez/Fabric-Atlas-Dev-Architecture.pptx
+++ b/prez/Fabric-Atlas-Dev-Architecture.pptx
@@ -13,8 +13,7 @@
     <p:sldId id="261" r:id="rId7"/>
     <p:sldId id="262" r:id="rId8"/>
     <p:sldId id="267" r:id="rId18"/>
-    <p:sldId id="268" r:id="rId19"/>
-    <p:sldId id="269" r:id="rId20"/>
+    <p:sldId id="270" r:id="rId9"/>
     <p:sldId id="264" r:id="rId10"/>
     <p:sldId id="265" r:id="rId11"/>
     <p:sldId id="266" r:id="rId12"/>
@@ -805,146 +804,6 @@
 </p:notes>
 </file>
 
-<file path=ppt/notesSlides/notesSlide13.xml><?xml version="1.0" encoding="utf-8"?>
-<p:notes xmlns:a="http://schemas.openxmlformats.org/drawingml/2006/main" xmlns:p="http://schemas.openxmlformats.org/presentationml/2006/main" xmlns:r="http://schemas.openxmlformats.org/officeDocument/2006/relationships">
-  <p:cSld>
-    <p:spTree>
-      <p:nvGrpSpPr>
-        <p:cNvPr id="1" name=""/>
-        <p:cNvGrpSpPr/>
-        <p:nvPr/>
-      </p:nvGrpSpPr>
-      <p:grpSpPr>
-        <a:xfrm>
-          <a:off x="0" y="0"/>
-          <a:ext cx="0" cy="0"/>
-          <a:chOff x="0" y="0"/>
-          <a:chExt cx="0" cy="0"/>
-        </a:xfrm>
-      </p:grpSpPr>
-      <p:sp>
-        <p:nvSpPr>
-          <p:cNvPr id="2" name="Slide Image Placeholder 1"/>
-          <p:cNvSpPr>
-            <a:spLocks noGrp="1"/>
-          </p:cNvSpPr>
-          <p:nvPr>
-            <p:ph type="sldImg" idx="2"/>
-          </p:nvPr>
-        </p:nvSpPr>
-        <p:spPr/>
-      </p:sp>
-      <p:sp>
-        <p:nvSpPr>
-          <p:cNvPr id="3" name="Notes Placeholder 2"/>
-          <p:cNvSpPr>
-            <a:spLocks noGrp="1"/>
-          </p:cNvSpPr>
-          <p:nvPr>
-            <p:ph type="body" idx="3" sz="quarter"/>
-          </p:nvPr>
-        </p:nvSpPr>
-        <p:spPr/>
-        <p:txBody>
-          <a:bodyPr/>
-          <a:lstStyle/>
-          <a:p>
-            <a:r>
-              <a:t>This physical model is derived from the declared Rayfin entities and the installed Rayfin MSSQL type mapper. It is not a live database inspection. Rayfin pluralizes entity names for table names. UUID fields become UNIQUEIDENTIFIER, bounded text becomes NVARCHAR, dates become DATETIME2, booleans become BIT and sets become NVARCHAR columns with CHECK constraints.</a:t>
-            </a:r>
-          </a:p>
-        </p:txBody>
-      </p:sp>
-      <p:sp>
-        <p:nvSpPr>
-          <p:cNvPr id="4" name="Slide Number Placeholder 3"/>
-          <p:cNvSpPr>
-            <a:spLocks noGrp="1"/>
-          </p:cNvSpPr>
-          <p:nvPr>
-            <p:ph type="sldNum" idx="5" sz="quarter"/>
-          </p:nvPr>
-        </p:nvSpPr>
-        <p:spPr/>
-      </p:sp>
-    </p:spTree>
-  </p:cSld>
-  <p:clrMapOvr>
-    <a:masterClrMapping/>
-  </p:clrMapOvr>
-</p:notes>
-</file>
-
-<file path=ppt/notesSlides/notesSlide14.xml><?xml version="1.0" encoding="utf-8"?>
-<p:notes xmlns:a="http://schemas.openxmlformats.org/drawingml/2006/main" xmlns:p="http://schemas.openxmlformats.org/presentationml/2006/main" xmlns:r="http://schemas.openxmlformats.org/officeDocument/2006/relationships">
-  <p:cSld>
-    <p:spTree>
-      <p:nvGrpSpPr>
-        <p:cNvPr id="1" name=""/>
-        <p:cNvGrpSpPr/>
-        <p:nvPr/>
-      </p:nvGrpSpPr>
-      <p:grpSpPr>
-        <a:xfrm>
-          <a:off x="0" y="0"/>
-          <a:ext cx="0" cy="0"/>
-          <a:chOff x="0" y="0"/>
-          <a:chExt cx="0" cy="0"/>
-        </a:xfrm>
-      </p:grpSpPr>
-      <p:sp>
-        <p:nvSpPr>
-          <p:cNvPr id="2" name="Slide Image Placeholder 1"/>
-          <p:cNvSpPr>
-            <a:spLocks noGrp="1"/>
-          </p:cNvSpPr>
-          <p:nvPr>
-            <p:ph type="sldImg" idx="2"/>
-          </p:nvPr>
-        </p:nvSpPr>
-        <p:spPr/>
-      </p:sp>
-      <p:sp>
-        <p:nvSpPr>
-          <p:cNvPr id="3" name="Notes Placeholder 2"/>
-          <p:cNvSpPr>
-            <a:spLocks noGrp="1"/>
-          </p:cNvSpPr>
-          <p:nvPr>
-            <p:ph type="body" idx="3" sz="quarter"/>
-          </p:nvPr>
-        </p:nvSpPr>
-        <p:spPr/>
-        <p:txBody>
-          <a:bodyPr/>
-          <a:lstStyle/>
-          <a:p>
-            <a:r>
-              <a:t>The access and audit tables follow the same physical mapping. workspace_id and snapshotId support scoped reads. principalRef and itemFabricId are text-based logical references. Rayfin would generate foreign keys from @one and @many decorators, but the Atlas entities do not declare those navigation properties, so this model contains no generated SQL foreign keys.</a:t>
-            </a:r>
-          </a:p>
-        </p:txBody>
-      </p:sp>
-      <p:sp>
-        <p:nvSpPr>
-          <p:cNvPr id="4" name="Slide Number Placeholder 3"/>
-          <p:cNvSpPr>
-            <a:spLocks noGrp="1"/>
-          </p:cNvSpPr>
-          <p:nvPr>
-            <p:ph type="sldNum" idx="5" sz="quarter"/>
-          </p:nvPr>
-        </p:nvSpPr>
-        <p:spPr/>
-      </p:sp>
-    </p:spTree>
-  </p:cSld>
-  <p:clrMapOvr>
-    <a:masterClrMapping/>
-  </p:clrMapOvr>
-</p:notes>
-</file>
-
 <file path=ppt/notesSlides/notesSlide2.xml><?xml version="1.0" encoding="utf-8"?>
 <p:notes xmlns:a="http://schemas.openxmlformats.org/drawingml/2006/main" xmlns:r="http://schemas.openxmlformats.org/officeDocument/2006/relationships" xmlns:p="http://schemas.openxmlformats.org/presentationml/2006/main">
   <p:cSld>
@@ -1472,6 +1331,76 @@
         <p14:creationId xmlns:p14="http://schemas.microsoft.com/office/powerpoint/2010/main" val="1024086991"/>
       </p:ext>
     </p:extLst>
+  </p:cSld>
+  <p:clrMapOvr>
+    <a:masterClrMapping/>
+  </p:clrMapOvr>
+</p:notes>
+</file>
+
+<file path=ppt/notesSlides/notesSlide8.xml><?xml version="1.0" encoding="utf-8"?>
+<p:notes xmlns:a="http://schemas.openxmlformats.org/drawingml/2006/main" xmlns:p="http://schemas.openxmlformats.org/presentationml/2006/main" xmlns:r="http://schemas.openxmlformats.org/officeDocument/2006/relationships">
+  <p:cSld>
+    <p:spTree>
+      <p:nvGrpSpPr>
+        <p:cNvPr id="1" name=""/>
+        <p:cNvGrpSpPr/>
+        <p:nvPr/>
+      </p:nvGrpSpPr>
+      <p:grpSpPr>
+        <a:xfrm>
+          <a:off x="0" y="0"/>
+          <a:ext cx="0" cy="0"/>
+          <a:chOff x="0" y="0"/>
+          <a:chExt cx="0" cy="0"/>
+        </a:xfrm>
+      </p:grpSpPr>
+      <p:sp>
+        <p:nvSpPr>
+          <p:cNvPr id="2" name="Slide Image Placeholder 1"/>
+          <p:cNvSpPr>
+            <a:spLocks noGrp="1"/>
+          </p:cNvSpPr>
+          <p:nvPr>
+            <p:ph type="sldImg" idx="2"/>
+          </p:nvPr>
+        </p:nvSpPr>
+        <p:spPr/>
+      </p:sp>
+      <p:sp>
+        <p:nvSpPr>
+          <p:cNvPr id="3" name="Notes Placeholder 2"/>
+          <p:cNvSpPr>
+            <a:spLocks noGrp="1"/>
+          </p:cNvSpPr>
+          <p:nvPr>
+            <p:ph type="body" idx="3" sz="quarter"/>
+          </p:nvPr>
+        </p:nvSpPr>
+        <p:spPr/>
+        <p:txBody>
+          <a:bodyPr/>
+          <a:lstStyle/>
+          <a:p>
+            <a:r>
+              <a:t>This MPD is derived from all fifteen declared Rayfin entity classes and the installed Rayfin MSSQL type mapper. It is not a live database inspection. Each table has a UNIQUEIDENTIFIER primary key named id. Required fields are NOT NULL, optional fields are NULL, bounded strings use NVARCHAR, dates use DATETIME2, booleans use BIT, and sets use NVARCHAR with CHECK constraints. The dashed lines are logical Atlas references through workspace_id, snapshotId, fabricId, itemFabricId, principalRef, and user_id. Atlas declares no @one or @many navigation properties, so Rayfin does not generate SQL foreign-key constraints for these links.</a:t>
+            </a:r>
+          </a:p>
+        </p:txBody>
+      </p:sp>
+      <p:sp>
+        <p:nvSpPr>
+          <p:cNvPr id="4" name="Slide Number Placeholder 3"/>
+          <p:cNvSpPr>
+            <a:spLocks noGrp="1"/>
+          </p:cNvSpPr>
+          <p:nvPr>
+            <p:ph type="sldNum" idx="5" sz="quarter"/>
+          </p:nvPr>
+        </p:nvSpPr>
+        <p:spPr/>
+      </p:sp>
+    </p:spTree>
   </p:cSld>
   <p:clrMapOvr>
     <a:masterClrMapping/>
@@ -2192,7 +2121,7 @@
                 <a:ea typeface="Segoe UI" pitchFamily="34" charset="-122"/>
                 <a:cs typeface="Segoe UI" pitchFamily="34" charset="-120"/>
               </a:rPr>
-              <a:t>13 slides · September 2026 · Fabric Atlas 1.12.4</a:t>
+              <a:t>12 slides · September 2026 · Fabric Atlas 1.12.4</a:t>
             </a:r>
             <a:endParaRPr lang="en-GB" sz="1200" dirty="0"/>
           </a:p>
@@ -2206,7 +2135,939 @@
 </p:sld>
 </file>
 
-<file path=ppt/slides/slide10.xml><?xml version="1.0" encoding="utf-8"?>
+<file path=ppt/slides/slide11.xml><?xml version="1.0" encoding="utf-8"?>
+<p:sld xmlns:a="http://schemas.openxmlformats.org/drawingml/2006/main" xmlns:r="http://schemas.openxmlformats.org/officeDocument/2006/relationships" xmlns:p="http://schemas.openxmlformats.org/presentationml/2006/main">
+  <p:cSld name="Slide 9">
+    <p:bg>
+      <p:bgPr>
+        <a:solidFill>
+          <a:srgbClr val="FFFFFF"/>
+        </a:solidFill>
+      </p:bgPr>
+    </p:bg>
+    <p:spTree>
+      <p:nvGrpSpPr>
+        <p:cNvPr id="1" name=""/>
+        <p:cNvGrpSpPr/>
+        <p:nvPr/>
+      </p:nvGrpSpPr>
+      <p:grpSpPr>
+        <a:xfrm>
+          <a:off x="0" y="0"/>
+          <a:ext cx="0" cy="0"/>
+          <a:chOff x="0" y="0"/>
+          <a:chExt cx="0" cy="0"/>
+        </a:xfrm>
+      </p:grpSpPr>
+      <p:sp>
+        <p:nvSpPr>
+          <p:cNvPr id="2" name="Text 0"/>
+          <p:cNvSpPr/>
+          <p:nvPr/>
+        </p:nvSpPr>
+        <p:spPr>
+          <a:xfrm>
+            <a:off x="530352" y="237744"/>
+            <a:ext cx="4206240" cy="219456"/>
+          </a:xfrm>
+          <a:prstGeom prst="rect">
+            <a:avLst/>
+          </a:prstGeom>
+          <a:noFill/>
+          <a:ln/>
+        </p:spPr>
+        <p:txBody>
+          <a:bodyPr wrap="square" lIns="0" tIns="0" rIns="0" bIns="0" rtlCol="0" anchor="t"/>
+          <a:lstStyle/>
+          <a:p>
+            <a:pPr algn="l" indent="0" marL="0">
+              <a:buNone/>
+            </a:pPr>
+            <a:r>
+              <a:rPr lang="en-GB" altLang="en-US" sz="1150" b="1" dirty="0">
+                <a:solidFill>
+                  <a:srgbClr val="117865"/>
+                </a:solidFill>
+                <a:latin typeface="Segoe UI" pitchFamily="34" charset="0"/>
+                <a:ea typeface="Segoe UI" pitchFamily="34" charset="-122"/>
+                <a:cs typeface="Segoe UI" pitchFamily="34" charset="-120"/>
+              </a:rPr>
+              <a:t>RAYFIN SCHEMA GENERATION</a:t>
+            </a:r>
+            <a:endParaRPr lang="en-GB" sz="1150" dirty="0"/>
+          </a:p>
+        </p:txBody>
+      </p:sp>
+      <p:sp>
+        <p:nvSpPr>
+          <p:cNvPr id="3" name="Text 1"/>
+          <p:cNvSpPr/>
+          <p:nvPr/>
+        </p:nvSpPr>
+        <p:spPr>
+          <a:xfrm>
+            <a:off x="530352" y="548640"/>
+            <a:ext cx="10972800" cy="932688"/>
+          </a:xfrm>
+          <a:prstGeom prst="rect">
+            <a:avLst/>
+          </a:prstGeom>
+          <a:noFill/>
+          <a:ln/>
+        </p:spPr>
+        <p:txBody>
+          <a:bodyPr wrap="square" lIns="0" tIns="0" rIns="0" bIns="0" rtlCol="0" anchor="t"/>
+          <a:lstStyle/>
+          <a:p>
+            <a:pPr algn="l" indent="0" marL="0">
+              <a:buNone/>
+            </a:pPr>
+            <a:r>
+              <a:rPr lang="en-GB" altLang="en-US" sz="2750" b="1" dirty="0">
+                <a:solidFill>
+                  <a:srgbClr val="242424"/>
+                </a:solidFill>
+                <a:latin typeface="Segoe UI" pitchFamily="34" charset="0"/>
+                <a:ea typeface="Segoe UI" pitchFamily="34" charset="-122"/>
+                <a:cs typeface="Segoe UI" pitchFamily="34" charset="-120"/>
+              </a:rPr>
+              <a:t>Rayfin turns decorated TypeScript classes into the Fabric SQL data model.</a:t>
+            </a:r>
+            <a:endParaRPr lang="en-GB" sz="2750" dirty="0"/>
+          </a:p>
+        </p:txBody>
+      </p:sp>
+      <p:sp>
+        <p:nvSpPr>
+          <p:cNvPr id="4" name="Shape 2"/>
+          <p:cNvSpPr/>
+          <p:nvPr/>
+        </p:nvSpPr>
+        <p:spPr>
+          <a:xfrm>
+            <a:off x="690829" y="1764198"/>
+            <a:ext cx="1926069" cy="892569"/>
+          </a:xfrm>
+          <a:prstGeom prst="roundRect">
+            <a:avLst>
+              <a:gd name="adj" fmla="val 8421"/>
+            </a:avLst>
+          </a:prstGeom>
+          <a:solidFill>
+            <a:srgbClr val="E3F7EF"/>
+          </a:solidFill>
+          <a:ln w="15240">
+            <a:solidFill>
+              <a:srgbClr val="117865"/>
+            </a:solidFill>
+            <a:prstDash val="solid"/>
+          </a:ln>
+        </p:spPr>
+        <p:txBody>
+          <a:bodyPr/>
+          <a:p/>
+        </p:txBody>
+      </p:sp>
+      <p:sp>
+        <p:nvSpPr>
+          <p:cNvPr id="5" name="Text 3"/>
+          <p:cNvSpPr/>
+          <p:nvPr/>
+        </p:nvSpPr>
+        <p:spPr>
+          <a:xfrm>
+            <a:off x="841157" y="1858152"/>
+            <a:ext cx="1625415" cy="507355"/>
+          </a:xfrm>
+          <a:prstGeom prst="rect">
+            <a:avLst/>
+          </a:prstGeom>
+          <a:noFill/>
+          <a:ln/>
+        </p:spPr>
+        <p:txBody>
+          <a:bodyPr wrap="square" lIns="0" tIns="0" rIns="0" bIns="0" rtlCol="0" anchor="t"/>
+          <a:lstStyle/>
+          <a:p>
+            <a:pPr algn="ctr" indent="0" marL="0">
+              <a:buNone/>
+            </a:pPr>
+            <a:r>
+              <a:rPr lang="en-GB" altLang="en-US" sz="1562" b="1" dirty="0">
+                <a:solidFill>
+                  <a:srgbClr val="0C695A"/>
+                </a:solidFill>
+                <a:latin typeface="Segoe UI" pitchFamily="34" charset="0"/>
+                <a:ea typeface="Segoe UI" pitchFamily="34" charset="-122"/>
+                <a:cs typeface="Segoe UI" pitchFamily="34" charset="-120"/>
+              </a:rPr>
+              <a:t>TypeScript</a:t>
+            </a:r>
+            <a:endParaRPr lang="en-GB" sz="1562" dirty="0"/>
+          </a:p>
+          <a:p>
+            <a:pPr algn="ctr" indent="0" marL="0">
+              <a:buNone/>
+            </a:pPr>
+            <a:r>
+              <a:rPr lang="en-GB" altLang="en-US" sz="1562" b="1" dirty="0">
+                <a:solidFill>
+                  <a:srgbClr val="0C695A"/>
+                </a:solidFill>
+                <a:latin typeface="Segoe UI" pitchFamily="34" charset="0"/>
+                <a:ea typeface="Segoe UI" pitchFamily="34" charset="-122"/>
+                <a:cs typeface="Segoe UI" pitchFamily="34" charset="-120"/>
+              </a:rPr>
+              <a:t>entities</a:t>
+            </a:r>
+            <a:endParaRPr lang="en-GB" sz="1562" dirty="0"/>
+          </a:p>
+        </p:txBody>
+      </p:sp>
+      <p:sp>
+        <p:nvSpPr>
+          <p:cNvPr id="6" name="Text 4"/>
+          <p:cNvSpPr/>
+          <p:nvPr/>
+        </p:nvSpPr>
+        <p:spPr>
+          <a:xfrm>
+            <a:off x="841157" y="2384298"/>
+            <a:ext cx="1625415" cy="310050"/>
+          </a:xfrm>
+          <a:prstGeom prst="rect">
+            <a:avLst/>
+          </a:prstGeom>
+          <a:noFill/>
+          <a:ln/>
+        </p:spPr>
+        <p:txBody>
+          <a:bodyPr wrap="square" lIns="0" tIns="0" rIns="0" bIns="0" rtlCol="0" anchor="t"/>
+          <a:lstStyle/>
+          <a:p>
+            <a:pPr algn="ctr" indent="0" marL="0">
+              <a:buNone/>
+            </a:pPr>
+            <a:r>
+              <a:rPr lang="en-GB" altLang="en-US" sz="1151" dirty="0">
+                <a:solidFill>
+                  <a:srgbClr val="616161"/>
+                </a:solidFill>
+                <a:latin typeface="Segoe UI" pitchFamily="34" charset="0"/>
+                <a:ea typeface="Segoe UI" pitchFamily="34" charset="-122"/>
+                <a:cs typeface="Segoe UI" pitchFamily="34" charset="-120"/>
+              </a:rPr>
+              <a:t>@entity · fields · policies</a:t>
+            </a:r>
+            <a:endParaRPr lang="en-GB" sz="1151" dirty="0"/>
+          </a:p>
+        </p:txBody>
+      </p:sp>
+      <p:sp>
+        <p:nvSpPr>
+          <p:cNvPr id="7" name="Shape 5"/>
+          <p:cNvSpPr/>
+          <p:nvPr/>
+        </p:nvSpPr>
+        <p:spPr>
+          <a:xfrm>
+            <a:off x="2673271" y="2215180"/>
+            <a:ext cx="488564" cy="0"/>
+          </a:xfrm>
+          <a:prstGeom prst="line">
+            <a:avLst/>
+          </a:prstGeom>
+          <a:noFill/>
+          <a:ln w="23489">
+            <a:solidFill>
+              <a:srgbClr val="117865"/>
+            </a:solidFill>
+            <a:prstDash val="solid"/>
+            <a:tailEnd type="triangle"/>
+          </a:ln>
+        </p:spPr>
+        <p:txBody>
+          <a:bodyPr/>
+          <a:p/>
+        </p:txBody>
+      </p:sp>
+      <p:sp>
+        <p:nvSpPr>
+          <p:cNvPr id="8" name="Shape 6"/>
+          <p:cNvSpPr/>
+          <p:nvPr/>
+        </p:nvSpPr>
+        <p:spPr>
+          <a:xfrm>
+            <a:off x="3227603" y="1764198"/>
+            <a:ext cx="1362342" cy="892569"/>
+          </a:xfrm>
+          <a:prstGeom prst="roundRect">
+            <a:avLst>
+              <a:gd name="adj" fmla="val 8421"/>
+            </a:avLst>
+          </a:prstGeom>
+          <a:solidFill>
+            <a:srgbClr val="E3F7EF"/>
+          </a:solidFill>
+          <a:ln w="15240">
+            <a:solidFill>
+              <a:srgbClr val="117865"/>
+            </a:solidFill>
+            <a:prstDash val="solid"/>
+          </a:ln>
+        </p:spPr>
+        <p:txBody>
+          <a:bodyPr/>
+          <a:p/>
+        </p:txBody>
+      </p:sp>
+      <p:sp>
+        <p:nvSpPr>
+          <p:cNvPr id="9" name="Text 7"/>
+          <p:cNvSpPr/>
+          <p:nvPr/>
+        </p:nvSpPr>
+        <p:spPr>
+          <a:xfrm>
+            <a:off x="3368535" y="2046061"/>
+            <a:ext cx="1080478" cy="263073"/>
+          </a:xfrm>
+          <a:prstGeom prst="rect">
+            <a:avLst/>
+          </a:prstGeom>
+          <a:noFill/>
+          <a:ln/>
+        </p:spPr>
+        <p:txBody>
+          <a:bodyPr wrap="square" lIns="0" tIns="0" rIns="0" bIns="0" rtlCol="0" anchor="t"/>
+          <a:lstStyle/>
+          <a:p>
+            <a:pPr algn="ctr" indent="0" marL="0">
+              <a:buNone/>
+            </a:pPr>
+            <a:r>
+              <a:rPr lang="en-GB" altLang="en-US" sz="1644" b="1" dirty="0">
+                <a:solidFill>
+                  <a:srgbClr val="0C695A"/>
+                </a:solidFill>
+                <a:latin typeface="Segoe UI" pitchFamily="34" charset="0"/>
+                <a:ea typeface="Segoe UI" pitchFamily="34" charset="-122"/>
+                <a:cs typeface="Segoe UI" pitchFamily="34" charset="-120"/>
+              </a:rPr>
+              <a:t>schema.ts</a:t>
+            </a:r>
+            <a:endParaRPr lang="en-GB" sz="1644" dirty="0"/>
+          </a:p>
+        </p:txBody>
+      </p:sp>
+      <p:sp>
+        <p:nvSpPr>
+          <p:cNvPr id="10" name="Shape 8"/>
+          <p:cNvSpPr/>
+          <p:nvPr/>
+        </p:nvSpPr>
+        <p:spPr>
+          <a:xfrm>
+            <a:off x="4655713" y="2215180"/>
+            <a:ext cx="497959" cy="0"/>
+          </a:xfrm>
+          <a:prstGeom prst="line">
+            <a:avLst/>
+          </a:prstGeom>
+          <a:noFill/>
+          <a:ln w="23489">
+            <a:solidFill>
+              <a:srgbClr val="117865"/>
+            </a:solidFill>
+            <a:prstDash val="solid"/>
+            <a:tailEnd type="triangle"/>
+          </a:ln>
+        </p:spPr>
+        <p:txBody>
+          <a:bodyPr/>
+          <a:p/>
+        </p:txBody>
+      </p:sp>
+      <p:sp>
+        <p:nvSpPr>
+          <p:cNvPr id="11" name="Shape 9"/>
+          <p:cNvSpPr/>
+          <p:nvPr/>
+        </p:nvSpPr>
+        <p:spPr>
+          <a:xfrm>
+            <a:off x="5219441" y="1764198"/>
+            <a:ext cx="1277783" cy="892569"/>
+          </a:xfrm>
+          <a:prstGeom prst="roundRect">
+            <a:avLst>
+              <a:gd name="adj" fmla="val 8421"/>
+            </a:avLst>
+          </a:prstGeom>
+          <a:solidFill>
+            <a:srgbClr val="EFF6FC"/>
+          </a:solidFill>
+          <a:ln w="15240">
+            <a:solidFill>
+              <a:srgbClr val="0078D4"/>
+            </a:solidFill>
+            <a:prstDash val="solid"/>
+          </a:ln>
+        </p:spPr>
+        <p:txBody>
+          <a:bodyPr/>
+          <a:p/>
+        </p:txBody>
+      </p:sp>
+      <p:sp>
+        <p:nvSpPr>
+          <p:cNvPr id="12" name="Text 10"/>
+          <p:cNvSpPr/>
+          <p:nvPr/>
+        </p:nvSpPr>
+        <p:spPr>
+          <a:xfrm>
+            <a:off x="5369768" y="2046061"/>
+            <a:ext cx="977128" cy="263073"/>
+          </a:xfrm>
+          <a:prstGeom prst="rect">
+            <a:avLst/>
+          </a:prstGeom>
+          <a:noFill/>
+          <a:ln/>
+        </p:spPr>
+        <p:txBody>
+          <a:bodyPr wrap="square" lIns="0" tIns="0" rIns="0" bIns="0" rtlCol="0" anchor="t"/>
+          <a:lstStyle/>
+          <a:p>
+            <a:pPr algn="ctr" indent="0" marL="0">
+              <a:buNone/>
+            </a:pPr>
+            <a:r>
+              <a:rPr lang="en-GB" altLang="en-US" sz="1644" b="1" dirty="0">
+                <a:solidFill>
+                  <a:srgbClr val="0078D4"/>
+                </a:solidFill>
+                <a:latin typeface="Segoe UI" pitchFamily="34" charset="0"/>
+                <a:ea typeface="Segoe UI" pitchFamily="34" charset="-122"/>
+                <a:cs typeface="Segoe UI" pitchFamily="34" charset="-120"/>
+              </a:rPr>
+              <a:t>rayfin up</a:t>
+            </a:r>
+            <a:endParaRPr lang="en-GB" sz="1644" dirty="0"/>
+          </a:p>
+        </p:txBody>
+      </p:sp>
+      <p:sp>
+        <p:nvSpPr>
+          <p:cNvPr id="13" name="Shape 11"/>
+          <p:cNvSpPr/>
+          <p:nvPr/>
+        </p:nvSpPr>
+        <p:spPr>
+          <a:xfrm>
+            <a:off x="6732110" y="1595079"/>
+            <a:ext cx="1099269" cy="1230805"/>
+          </a:xfrm>
+          <a:prstGeom prst="roundRect">
+            <a:avLst>
+              <a:gd name="adj" fmla="val 6838"/>
+            </a:avLst>
+          </a:prstGeom>
+          <a:solidFill>
+            <a:srgbClr val="EFF6FC"/>
+          </a:solidFill>
+          <a:ln w="15240">
+            <a:solidFill>
+              <a:srgbClr val="0078D4"/>
+            </a:solidFill>
+            <a:prstDash val="solid"/>
+          </a:ln>
+        </p:spPr>
+        <p:txBody>
+          <a:bodyPr/>
+          <a:p/>
+        </p:txBody>
+      </p:sp>
+      <p:sp>
+        <p:nvSpPr>
+          <p:cNvPr id="14" name="Text 12"/>
+          <p:cNvSpPr/>
+          <p:nvPr/>
+        </p:nvSpPr>
+        <p:spPr>
+          <a:xfrm>
+            <a:off x="6826065" y="1698429"/>
+            <a:ext cx="911360" cy="1033501"/>
+          </a:xfrm>
+          <a:prstGeom prst="rect">
+            <a:avLst/>
+          </a:prstGeom>
+          <a:noFill/>
+          <a:ln/>
+        </p:spPr>
+        <p:txBody>
+          <a:bodyPr wrap="square" lIns="0" tIns="0" rIns="0" bIns="0" rtlCol="0" anchor="t"/>
+          <a:lstStyle/>
+          <a:p>
+            <a:pPr algn="ctr" indent="0" marL="0">
+              <a:buNone/>
+            </a:pPr>
+            <a:r>
+              <a:rPr lang="en-GB" altLang="en-US" sz="1161" b="1" dirty="0">
+                <a:solidFill>
+                  <a:srgbClr val="242424"/>
+                </a:solidFill>
+                <a:latin typeface="Segoe UI" pitchFamily="34" charset="0"/>
+                <a:ea typeface="Segoe UI" pitchFamily="34" charset="-122"/>
+                <a:cs typeface="Segoe UI" pitchFamily="34" charset="-120"/>
+              </a:rPr>
+              <a:t>Data API</a:t>
+            </a:r>
+            <a:endParaRPr lang="en-GB" sz="1161" dirty="0"/>
+          </a:p>
+          <a:p>
+            <a:pPr algn="ctr" indent="0" marL="0">
+              <a:buNone/>
+            </a:pPr>
+            <a:r>
+              <a:rPr lang="en-GB" altLang="en-US" sz="1161" b="1" dirty="0">
+                <a:solidFill>
+                  <a:srgbClr val="242424"/>
+                </a:solidFill>
+                <a:latin typeface="Segoe UI" pitchFamily="34" charset="0"/>
+                <a:ea typeface="Segoe UI" pitchFamily="34" charset="-122"/>
+                <a:cs typeface="Segoe UI" pitchFamily="34" charset="-120"/>
+              </a:rPr>
+              <a:t>Builder</a:t>
+            </a:r>
+            <a:endParaRPr lang="en-GB" sz="1161" dirty="0"/>
+          </a:p>
+          <a:p>
+            <a:pPr algn="ctr" indent="0" marL="0">
+              <a:buNone/>
+            </a:pPr>
+            <a:r>
+              <a:rPr lang="en-GB" altLang="en-US" sz="1161" b="1" dirty="0">
+                <a:solidFill>
+                  <a:srgbClr val="242424"/>
+                </a:solidFill>
+                <a:latin typeface="Segoe UI" pitchFamily="34" charset="0"/>
+                <a:ea typeface="Segoe UI" pitchFamily="34" charset="-122"/>
+                <a:cs typeface="Segoe UI" pitchFamily="34" charset="-120"/>
+              </a:rPr>
+              <a:t>+</a:t>
+            </a:r>
+            <a:endParaRPr lang="en-GB" sz="1161" dirty="0"/>
+          </a:p>
+          <a:p>
+            <a:pPr algn="ctr" indent="0" marL="0">
+              <a:buNone/>
+            </a:pPr>
+            <a:r>
+              <a:rPr lang="en-GB" altLang="en-US" sz="1161" b="1" dirty="0">
+                <a:solidFill>
+                  <a:srgbClr val="242424"/>
+                </a:solidFill>
+                <a:latin typeface="Segoe UI" pitchFamily="34" charset="0"/>
+                <a:ea typeface="Segoe UI" pitchFamily="34" charset="-122"/>
+                <a:cs typeface="Segoe UI" pitchFamily="34" charset="-120"/>
+              </a:rPr>
+              <a:t>Fabric SQL</a:t>
+            </a:r>
+            <a:endParaRPr lang="en-GB" sz="1161" dirty="0"/>
+          </a:p>
+        </p:txBody>
+      </p:sp>
+      <p:sp>
+        <p:nvSpPr>
+          <p:cNvPr id="15" name="Shape 13"/>
+          <p:cNvSpPr/>
+          <p:nvPr/>
+        </p:nvSpPr>
+        <p:spPr>
+          <a:xfrm>
+            <a:off x="6562992" y="2215180"/>
+            <a:ext cx="150327" cy="0"/>
+          </a:xfrm>
+          <a:prstGeom prst="line">
+            <a:avLst/>
+          </a:prstGeom>
+          <a:noFill/>
+          <a:ln w="23489">
+            <a:solidFill>
+              <a:srgbClr val="0078D4"/>
+            </a:solidFill>
+            <a:prstDash val="solid"/>
+            <a:tailEnd type="triangle"/>
+          </a:ln>
+        </p:spPr>
+        <p:txBody>
+          <a:bodyPr/>
+          <a:p/>
+        </p:txBody>
+      </p:sp>
+      <p:sp>
+        <p:nvSpPr>
+          <p:cNvPr id="16" name="Shape 14"/>
+          <p:cNvSpPr/>
+          <p:nvPr/>
+        </p:nvSpPr>
+        <p:spPr>
+          <a:xfrm>
+            <a:off x="3227603" y="3530544"/>
+            <a:ext cx="1747556" cy="1033501"/>
+          </a:xfrm>
+          <a:prstGeom prst="roundRect">
+            <a:avLst>
+              <a:gd name="adj" fmla="val 7273"/>
+            </a:avLst>
+          </a:prstGeom>
+          <a:solidFill>
+            <a:srgbClr val="E3F7EF"/>
+          </a:solidFill>
+          <a:ln w="15240">
+            <a:solidFill>
+              <a:srgbClr val="117865"/>
+            </a:solidFill>
+            <a:prstDash val="solid"/>
+          </a:ln>
+        </p:spPr>
+        <p:txBody>
+          <a:bodyPr/>
+          <a:p/>
+        </p:txBody>
+      </p:sp>
+      <p:sp>
+        <p:nvSpPr>
+          <p:cNvPr id="17" name="Text 15"/>
+          <p:cNvSpPr/>
+          <p:nvPr/>
+        </p:nvSpPr>
+        <p:spPr>
+          <a:xfrm>
+            <a:off x="3387326" y="3699662"/>
+            <a:ext cx="1428110" cy="704660"/>
+          </a:xfrm>
+          <a:prstGeom prst="rect">
+            <a:avLst/>
+          </a:prstGeom>
+          <a:noFill/>
+          <a:ln/>
+        </p:spPr>
+        <p:txBody>
+          <a:bodyPr wrap="square" lIns="0" tIns="0" rIns="0" bIns="0" rtlCol="0" anchor="t"/>
+          <a:lstStyle/>
+          <a:p>
+            <a:pPr algn="ctr" indent="0" marL="0">
+              <a:buNone/>
+            </a:pPr>
+            <a:r>
+              <a:rPr lang="en-GB" altLang="en-US" sz="1315" b="1" dirty="0">
+                <a:solidFill>
+                  <a:srgbClr val="0C695A"/>
+                </a:solidFill>
+                <a:latin typeface="Segoe UI" pitchFamily="34" charset="0"/>
+                <a:ea typeface="Segoe UI" pitchFamily="34" charset="-122"/>
+                <a:cs typeface="Segoe UI" pitchFamily="34" charset="-120"/>
+              </a:rPr>
+              <a:t>RayfinClient</a:t>
+            </a:r>
+            <a:endParaRPr lang="en-GB" sz="1315" dirty="0"/>
+          </a:p>
+          <a:p>
+            <a:pPr algn="ctr" indent="0" marL="0">
+              <a:buNone/>
+            </a:pPr>
+            <a:r>
+              <a:rPr lang="en-GB" altLang="en-US" sz="1315" b="1" dirty="0">
+                <a:solidFill>
+                  <a:srgbClr val="0C695A"/>
+                </a:solidFill>
+                <a:latin typeface="Segoe UI" pitchFamily="34" charset="0"/>
+                <a:ea typeface="Segoe UI" pitchFamily="34" charset="-122"/>
+                <a:cs typeface="Segoe UI" pitchFamily="34" charset="-120"/>
+              </a:rPr>
+              <a:t>typed GraphQL proxies</a:t>
+            </a:r>
+            <a:endParaRPr lang="en-GB" sz="1315" dirty="0"/>
+          </a:p>
+        </p:txBody>
+      </p:sp>
+      <p:sp>
+        <p:nvSpPr>
+          <p:cNvPr id="18" name="Shape 16"/>
+          <p:cNvSpPr/>
+          <p:nvPr/>
+        </p:nvSpPr>
+        <p:spPr>
+          <a:xfrm>
+            <a:off x="3913472" y="2722535"/>
+            <a:ext cx="0" cy="742241"/>
+          </a:xfrm>
+          <a:prstGeom prst="line">
+            <a:avLst/>
+          </a:prstGeom>
+          <a:noFill/>
+          <a:ln w="23489">
+            <a:solidFill>
+              <a:srgbClr val="117865"/>
+            </a:solidFill>
+            <a:prstDash val="solid"/>
+            <a:tailEnd type="triangle"/>
+          </a:ln>
+        </p:spPr>
+        <p:txBody>
+          <a:bodyPr/>
+          <a:p/>
+        </p:txBody>
+      </p:sp>
+      <p:sp>
+        <p:nvSpPr>
+          <p:cNvPr id="19" name="Shape 17"/>
+          <p:cNvSpPr/>
+          <p:nvPr/>
+        </p:nvSpPr>
+        <p:spPr>
+          <a:xfrm>
+            <a:off x="5031532" y="3981526"/>
+            <a:ext cx="1277783" cy="0"/>
+          </a:xfrm>
+          <a:prstGeom prst="line">
+            <a:avLst/>
+          </a:prstGeom>
+          <a:noFill/>
+          <a:ln w="23489">
+            <a:solidFill>
+              <a:srgbClr val="117865"/>
+            </a:solidFill>
+            <a:prstDash val="solid"/>
+          </a:ln>
+        </p:spPr>
+        <p:txBody>
+          <a:bodyPr/>
+          <a:p/>
+        </p:txBody>
+      </p:sp>
+      <p:sp>
+        <p:nvSpPr>
+          <p:cNvPr id="20" name="Shape 18"/>
+          <p:cNvSpPr/>
+          <p:nvPr/>
+        </p:nvSpPr>
+        <p:spPr>
+          <a:xfrm>
+            <a:off x="6309314" y="2778907"/>
+            <a:ext cx="0" cy="1202619"/>
+          </a:xfrm>
+          <a:prstGeom prst="line">
+            <a:avLst/>
+          </a:prstGeom>
+          <a:noFill/>
+          <a:ln w="23489">
+            <a:solidFill>
+              <a:srgbClr val="117865"/>
+            </a:solidFill>
+            <a:prstDash val="solid"/>
+          </a:ln>
+        </p:spPr>
+        <p:txBody>
+          <a:bodyPr/>
+          <a:p/>
+        </p:txBody>
+      </p:sp>
+      <p:sp>
+        <p:nvSpPr>
+          <p:cNvPr id="21" name="Shape 19"/>
+          <p:cNvSpPr/>
+          <p:nvPr/>
+        </p:nvSpPr>
+        <p:spPr>
+          <a:xfrm>
+            <a:off x="6309314" y="2778907"/>
+            <a:ext cx="404005" cy="0"/>
+          </a:xfrm>
+          <a:prstGeom prst="line">
+            <a:avLst/>
+          </a:prstGeom>
+          <a:noFill/>
+          <a:ln w="23489">
+            <a:solidFill>
+              <a:srgbClr val="117865"/>
+            </a:solidFill>
+            <a:prstDash val="solid"/>
+            <a:tailEnd type="triangle"/>
+          </a:ln>
+        </p:spPr>
+        <p:txBody>
+          <a:bodyPr/>
+          <a:p/>
+        </p:txBody>
+      </p:sp>
+      <p:sp>
+        <p:nvSpPr>
+          <p:cNvPr id="22" name="Text 20"/>
+          <p:cNvSpPr/>
+          <p:nvPr/>
+        </p:nvSpPr>
+        <p:spPr>
+          <a:xfrm>
+            <a:off x="8275320" y="1700784"/>
+            <a:ext cx="3246120" cy="3310128"/>
+          </a:xfrm>
+          <a:prstGeom prst="rect">
+            <a:avLst/>
+          </a:prstGeom>
+          <a:noFill/>
+          <a:ln/>
+        </p:spPr>
+        <p:txBody>
+          <a:bodyPr wrap="square" lIns="254" tIns="254" rIns="254" bIns="254" rtlCol="0" anchor="ctr"/>
+          <a:lstStyle/>
+          <a:p>
+            <a:pPr marL="243840" indent="-243840">
+              <a:buSzPct val="100000"/>
+              <a:buChar char="•"/>
+            </a:pPr>
+            <a:r>
+              <a:rPr lang="en-GB" altLang="en-US" sz="1600" dirty="0">
+                <a:solidFill>
+                  <a:srgbClr val="242424"/>
+                </a:solidFill>
+                <a:latin typeface="Segoe UI" pitchFamily="34" charset="0"/>
+                <a:ea typeface="Segoe UI" pitchFamily="34" charset="-122"/>
+                <a:cs typeface="Segoe UI" pitchFamily="34" charset="-120"/>
+              </a:rPr>
+              <a:t>Field decorators define SQL types, limits and optional values.</a:t>
+            </a:r>
+            <a:endParaRPr lang="en-GB" sz="1600" dirty="0"/>
+          </a:p>
+          <a:p>
+            <a:pPr marL="243840" indent="-243840">
+              <a:buSzPct val="100000"/>
+              <a:buChar char="•"/>
+            </a:pPr>
+            <a:r>
+              <a:rPr lang="en-GB" altLang="en-US" sz="1600" dirty="0">
+                <a:solidFill>
+                  <a:srgbClr val="242424"/>
+                </a:solidFill>
+                <a:latin typeface="Segoe UI" pitchFamily="34" charset="0"/>
+                <a:ea typeface="Segoe UI" pitchFamily="34" charset="-122"/>
+                <a:cs typeface="Segoe UI" pitchFamily="34" charset="-120"/>
+              </a:rPr>
+              <a:t>Authorization decorators generate read and write policies.</a:t>
+            </a:r>
+            <a:endParaRPr lang="en-GB" sz="1600" dirty="0"/>
+          </a:p>
+          <a:p>
+            <a:pPr marL="243840" indent="-243840">
+              <a:buSzPct val="100000"/>
+              <a:buChar char="•"/>
+            </a:pPr>
+            <a:r>
+              <a:rPr lang="en-GB" altLang="en-US" sz="1600" dirty="0">
+                <a:solidFill>
+                  <a:srgbClr val="242424"/>
+                </a:solidFill>
+                <a:latin typeface="Segoe UI" pitchFamily="34" charset="0"/>
+                <a:ea typeface="Segoe UI" pitchFamily="34" charset="-122"/>
+                <a:cs typeface="Segoe UI" pitchFamily="34" charset="-120"/>
+              </a:rPr>
+              <a:t>schema.ts registers the 15 entities used by RayfinClient.</a:t>
+            </a:r>
+            <a:endParaRPr lang="en-GB" sz="1600" dirty="0"/>
+          </a:p>
+        </p:txBody>
+      </p:sp>
+      <p:sp>
+        <p:nvSpPr>
+          <p:cNvPr id="23" name="Text 21"/>
+          <p:cNvSpPr/>
+          <p:nvPr/>
+        </p:nvSpPr>
+        <p:spPr>
+          <a:xfrm>
+            <a:off x="530352" y="6428232"/>
+            <a:ext cx="10149840" cy="182880"/>
+          </a:xfrm>
+          <a:prstGeom prst="rect">
+            <a:avLst/>
+          </a:prstGeom>
+          <a:noFill/>
+          <a:ln/>
+        </p:spPr>
+        <p:txBody>
+          <a:bodyPr wrap="square" lIns="0" tIns="0" rIns="0" bIns="0" rtlCol="0" anchor="t"/>
+          <a:lstStyle/>
+          <a:p>
+            <a:pPr algn="l" indent="0" marL="0">
+              <a:buNone/>
+            </a:pPr>
+            <a:r>
+              <a:rPr lang="en-GB" altLang="en-US" sz="1050" dirty="0">
+                <a:solidFill>
+                  <a:srgbClr val="616161"/>
+                </a:solidFill>
+                <a:latin typeface="Segoe UI" pitchFamily="34" charset="0"/>
+                <a:ea typeface="Segoe UI" pitchFamily="34" charset="-122"/>
+                <a:cs typeface="Segoe UI" pitchFamily="34" charset="-120"/>
+              </a:rPr>
+              <a:t>Source: eraser/05-rayfin-generation.eraser.txt · rayfin/data/schema.ts</a:t>
+            </a:r>
+            <a:endParaRPr lang="en-GB" sz="1050" dirty="0"/>
+          </a:p>
+        </p:txBody>
+      </p:sp>
+      <p:sp>
+        <p:nvSpPr>
+          <p:cNvPr id="24" name="Text 22"/>
+          <p:cNvSpPr/>
+          <p:nvPr/>
+        </p:nvSpPr>
+        <p:spPr>
+          <a:xfrm>
+            <a:off x="11109960" y="6428232"/>
+            <a:ext cx="502920" cy="182880"/>
+          </a:xfrm>
+          <a:prstGeom prst="rect">
+            <a:avLst/>
+          </a:prstGeom>
+          <a:noFill/>
+          <a:ln/>
+        </p:spPr>
+        <p:txBody>
+          <a:bodyPr wrap="square" lIns="0" tIns="0" rIns="0" bIns="0" rtlCol="0" anchor="t"/>
+          <a:lstStyle/>
+          <a:p>
+            <a:pPr algn="r" indent="0" marL="0">
+              <a:buNone/>
+            </a:pPr>
+            <a:r>
+              <a:rPr lang="en-GB" altLang="en-US" sz="1050" dirty="0">
+                <a:solidFill>
+                  <a:srgbClr val="616161"/>
+                </a:solidFill>
+                <a:latin typeface="Segoe UI" pitchFamily="34" charset="0"/>
+                <a:ea typeface="Segoe UI" pitchFamily="34" charset="-122"/>
+                <a:cs typeface="Segoe UI" pitchFamily="34" charset="-120"/>
+              </a:rPr>
+              <a:t>10</a:t>
+            </a:r>
+            <a:endParaRPr lang="en-GB" sz="1050" dirty="0"/>
+          </a:p>
+        </p:txBody>
+      </p:sp>
+    </p:spTree>
+  </p:cSld>
+  <p:clrMapOvr>
+    <a:masterClrMapping/>
+  </p:clrMapOvr>
+</p:sld>
+</file>
+
+<file path=ppt/slides/slide12.xml><?xml version="1.0" encoding="utf-8"?>
 <p:sld xmlns:a="http://schemas.openxmlformats.org/drawingml/2006/main" xmlns:r="http://schemas.openxmlformats.org/officeDocument/2006/relationships" xmlns:p="http://schemas.openxmlformats.org/presentationml/2006/main">
   <p:cSld name="Slide 10">
     <p:bg>
@@ -2606,7 +3467,7 @@
                 <a:ea typeface="Segoe UI" pitchFamily="34" charset="-122"/>
                 <a:cs typeface="Segoe UI" pitchFamily="34" charset="-120"/>
               </a:rPr>
-              <a:t>12</a:t>
+              <a:t>11</a:t>
             </a:r>
             <a:endParaRPr lang="en-GB" sz="1050" dirty="0"/>
           </a:p>
@@ -2620,7 +3481,7 @@
 </p:sld>
 </file>
 
-<file path=ppt/slides/slide11.xml><?xml version="1.0" encoding="utf-8"?>
+<file path=ppt/slides/slide13.xml><?xml version="1.0" encoding="utf-8"?>
 <p:sld xmlns:a="http://schemas.openxmlformats.org/drawingml/2006/main" xmlns:r="http://schemas.openxmlformats.org/officeDocument/2006/relationships" xmlns:p="http://schemas.openxmlformats.org/presentationml/2006/main">
   <p:cSld name="Slide 11">
     <p:bg>
@@ -3015,627 +3876,9 @@
                 <a:ea typeface="Segoe UI" pitchFamily="34" charset="-122"/>
                 <a:cs typeface="Segoe UI" pitchFamily="34" charset="-120"/>
               </a:rPr>
-              <a:t>13</a:t>
+              <a:t>12</a:t>
             </a:r>
             <a:endParaRPr lang="en-GB" sz="1050" dirty="0"/>
-          </a:p>
-        </p:txBody>
-      </p:sp>
-    </p:spTree>
-  </p:cSld>
-  <p:clrMapOvr>
-    <a:masterClrMapping/>
-  </p:clrMapOvr>
-</p:sld>
-</file>
-
-<file path=ppt/slides/slide12.xml><?xml version="1.0" encoding="utf-8"?>
-<p:sld xmlns:a="http://schemas.openxmlformats.org/drawingml/2006/main" xmlns:p="http://schemas.openxmlformats.org/presentationml/2006/main" xmlns:r="http://schemas.openxmlformats.org/officeDocument/2006/relationships">
-  <p:cSld>
-    <p:bg>
-      <p:bgPr>
-        <a:solidFill>
-          <a:srgbClr val="FFFFFF"/>
-        </a:solidFill>
-        <a:effectLst/>
-      </p:bgPr>
-    </p:bg>
-    <p:spTree>
-      <p:nvGrpSpPr>
-        <p:cNvPr id="1" name=""/>
-        <p:cNvGrpSpPr/>
-        <p:nvPr/>
-      </p:nvGrpSpPr>
-      <p:grpSpPr/>
-      <p:sp>
-        <p:nvSpPr>
-          <p:cNvPr id="2" name="TextBox 1"/>
-          <p:cNvSpPr txBox="1"/>
-          <p:nvPr/>
-        </p:nvSpPr>
-        <p:spPr>
-          <a:xfrm>
-            <a:off x="530352" y="237744"/>
-            <a:ext cx="4114800" cy="228600"/>
-          </a:xfrm>
-          <a:prstGeom prst="rect">
-            <a:avLst/>
-          </a:prstGeom>
-          <a:noFill/>
-        </p:spPr>
-        <p:txBody>
-          <a:bodyPr wrap="none" lIns="0" rIns="0" tIns="0" bIns="0" anchor="t">
-            <a:spAutoFit/>
-          </a:bodyPr>
-          <a:lstStyle/>
-          <a:p>
-            <a:pPr algn="l"/>
-            <a:r>
-              <a:rPr sz="1150" b="1">
-                <a:solidFill>
-                  <a:srgbClr val="117865"/>
-                </a:solidFill>
-                <a:latin typeface="Segoe UI"/>
-              </a:rPr>
-              <a:t>UML ENTITY MODEL</a:t>
-            </a:r>
-          </a:p>
-        </p:txBody>
-      </p:sp>
-      <p:sp>
-        <p:nvSpPr>
-          <p:cNvPr id="3" name="TextBox 2"/>
-          <p:cNvSpPr txBox="1"/>
-          <p:nvPr/>
-        </p:nvSpPr>
-        <p:spPr>
-          <a:xfrm>
-            <a:off x="530352" y="548640"/>
-            <a:ext cx="11018520" cy="841248"/>
-          </a:xfrm>
-          <a:prstGeom prst="rect">
-            <a:avLst/>
-          </a:prstGeom>
-          <a:noFill/>
-        </p:spPr>
-        <p:txBody>
-          <a:bodyPr wrap="none" lIns="0" rIns="0" tIns="0" bIns="0" anchor="t">
-            <a:spAutoFit/>
-          </a:bodyPr>
-          <a:lstStyle/>
-          <a:p>
-            <a:pPr algn="l"/>
-            <a:r>
-              <a:rPr sz="2750" b="1">
-                <a:solidFill>
-                  <a:srgbClr val="242424"/>
-                </a:solidFill>
-                <a:latin typeface="Segoe UI"/>
-              </a:rPr>
-              <a:t>The UML model shows entity classes and logical associations.</a:t>
-            </a:r>
-          </a:p>
-        </p:txBody>
-      </p:sp>
-      <p:sp>
-        <p:nvSpPr>
-          <p:cNvPr id="4" name="Rounded Rectangle 3"/>
-          <p:cNvSpPr/>
-          <p:nvPr/>
-        </p:nvSpPr>
-        <p:spPr>
-          <a:xfrm>
-            <a:off x="411480" y="1472184"/>
-            <a:ext cx="7726679" cy="4443984"/>
-          </a:xfrm>
-          <a:prstGeom prst="roundRect">
-            <a:avLst/>
-          </a:prstGeom>
-          <a:solidFill>
-            <a:srgbClr val="FFFFFF"/>
-          </a:solidFill>
-          <a:ln>
-            <a:solidFill>
-              <a:srgbClr val="E0E0E0"/>
-            </a:solidFill>
-          </a:ln>
-        </p:spPr>
-        <p:style>
-          <a:lnRef idx="1">
-            <a:schemeClr val="accent1"/>
-          </a:lnRef>
-          <a:fillRef idx="3">
-            <a:schemeClr val="accent1"/>
-          </a:fillRef>
-          <a:effectRef idx="2">
-            <a:schemeClr val="accent1"/>
-          </a:effectRef>
-          <a:fontRef idx="minor">
-            <a:schemeClr val="lt1"/>
-          </a:fontRef>
-        </p:style>
-        <p:txBody>
-          <a:bodyPr rtlCol="0" anchor="ctr"/>
-          <a:lstStyle/>
-          <a:p>
-            <a:pPr algn="ctr"/>
-          </a:p>
-        </p:txBody>
-      </p:sp>
-      <p:pic>
-        <p:nvPicPr>
-          <p:cNvPr id="5" name="Picture 4" descr="01-uml.png"/>
-          <p:cNvPicPr>
-            <a:picLocks noChangeAspect="1"/>
-          </p:cNvPicPr>
-          <p:nvPr/>
-        </p:nvPicPr>
-        <p:blipFill>
-          <a:blip r:embed="rId2"/>
-          <a:stretch>
-            <a:fillRect/>
-          </a:stretch>
-        </p:blipFill>
-        <p:spPr>
-          <a:xfrm>
-            <a:off x="1820732" y="1554480"/>
-            <a:ext cx="4908175" cy="4279392"/>
-          </a:xfrm>
-          <a:prstGeom prst="rect">
-            <a:avLst/>
-          </a:prstGeom>
-        </p:spPr>
-      </p:pic>
-      <p:sp>
-        <p:nvSpPr>
-          <p:cNvPr id="6" name="TextBox 5"/>
-          <p:cNvSpPr txBox="1"/>
-          <p:nvPr/>
-        </p:nvSpPr>
-        <p:spPr>
-          <a:xfrm>
-            <a:off x="8357616" y="1673352"/>
-            <a:ext cx="3227832" cy="4069080"/>
-          </a:xfrm>
-          <a:prstGeom prst="rect">
-            <a:avLst/>
-          </a:prstGeom>
-          <a:noFill/>
-        </p:spPr>
-        <p:txBody>
-          <a:bodyPr wrap="square" lIns="36576" rIns="0" tIns="0" bIns="0">
-            <a:spAutoFit/>
-          </a:bodyPr>
-          <a:lstStyle/>
-          <a:p>
-            <a:pPr>
-              <a:buChar char="•"/>
-              <a:spcAft>
-                <a:spcPts val="1800"/>
-              </a:spcAft>
-              <a:defRPr sz="1550">
-                <a:solidFill>
-                  <a:srgbClr val="242424"/>
-                </a:solidFill>
-                <a:latin typeface="Segoe UI"/>
-              </a:defRPr>
-            </a:pPr>
-            <a:r>
-              <a:t>Selected properties mirror the TypeScript entity classes.</a:t>
-            </a:r>
-          </a:p>
-          <a:p>
-            <a:pPr>
-              <a:buChar char="•"/>
-              <a:spcAft>
-                <a:spcPts val="1800"/>
-              </a:spcAft>
-              <a:defRPr sz="1550">
-                <a:solidFill>
-                  <a:srgbClr val="242424"/>
-                </a:solidFill>
-                <a:latin typeface="Segoe UI"/>
-              </a:defRPr>
-            </a:pPr>
-            <a:r>
-              <a:t>Workspace publishes a snapshot; FabricItem anchors item-level facts.</a:t>
-            </a:r>
-          </a:p>
-          <a:p>
-            <a:pPr>
-              <a:buChar char="•"/>
-              <a:spcAft>
-                <a:spcPts val="1800"/>
-              </a:spcAft>
-              <a:defRPr sz="1550">
-                <a:solidFill>
-                  <a:srgbClr val="242424"/>
-                </a:solidFill>
-                <a:latin typeface="Segoe UI"/>
-              </a:defRPr>
-            </a:pPr>
-            <a:r>
-              <a:t>Lines are logical associations, not Rayfin navigation decorators.</a:t>
-            </a:r>
-          </a:p>
-        </p:txBody>
-      </p:sp>
-      <p:sp>
-        <p:nvSpPr>
-          <p:cNvPr id="7" name="TextBox 6"/>
-          <p:cNvSpPr txBox="1"/>
-          <p:nvPr/>
-        </p:nvSpPr>
-        <p:spPr>
-          <a:xfrm>
-            <a:off x="530352" y="6428232"/>
-            <a:ext cx="10195560" cy="182880"/>
-          </a:xfrm>
-          <a:prstGeom prst="rect">
-            <a:avLst/>
-          </a:prstGeom>
-          <a:noFill/>
-        </p:spPr>
-        <p:txBody>
-          <a:bodyPr wrap="none" lIns="0" rIns="0" tIns="0" bIns="0" anchor="t">
-            <a:spAutoFit/>
-          </a:bodyPr>
-          <a:lstStyle/>
-          <a:p>
-            <a:pPr algn="l"/>
-            <a:r>
-              <a:rPr sz="1050" b="0">
-                <a:solidFill>
-                  <a:srgbClr val="616161"/>
-                </a:solidFill>
-                <a:latin typeface="Segoe UI"/>
-              </a:rPr>
-              <a:t>Source: rayfin/data/*.ts (15 classes)</a:t>
-            </a:r>
-          </a:p>
-        </p:txBody>
-      </p:sp>
-      <p:sp>
-        <p:nvSpPr>
-          <p:cNvPr id="8" name="TextBox 7"/>
-          <p:cNvSpPr txBox="1"/>
-          <p:nvPr/>
-        </p:nvSpPr>
-        <p:spPr>
-          <a:xfrm>
-            <a:off x="11109960" y="6428232"/>
-            <a:ext cx="502920" cy="182880"/>
-          </a:xfrm>
-          <a:prstGeom prst="rect">
-            <a:avLst/>
-          </a:prstGeom>
-          <a:noFill/>
-        </p:spPr>
-        <p:txBody>
-          <a:bodyPr wrap="none" lIns="0" rIns="0" tIns="0" bIns="0" anchor="t">
-            <a:spAutoFit/>
-          </a:bodyPr>
-          <a:lstStyle/>
-          <a:p>
-            <a:pPr algn="r"/>
-            <a:r>
-              <a:rPr sz="1050" b="0">
-                <a:solidFill>
-                  <a:srgbClr val="616161"/>
-                </a:solidFill>
-                <a:latin typeface="Segoe UI"/>
-              </a:rPr>
-              <a:t>8</a:t>
-            </a:r>
-          </a:p>
-        </p:txBody>
-      </p:sp>
-    </p:spTree>
-  </p:cSld>
-  <p:clrMapOvr>
-    <a:masterClrMapping/>
-  </p:clrMapOvr>
-</p:sld>
-</file>
-
-<file path=ppt/slides/slide13.xml><?xml version="1.0" encoding="utf-8"?>
-<p:sld xmlns:a="http://schemas.openxmlformats.org/drawingml/2006/main" xmlns:p="http://schemas.openxmlformats.org/presentationml/2006/main" xmlns:r="http://schemas.openxmlformats.org/officeDocument/2006/relationships">
-  <p:cSld>
-    <p:bg>
-      <p:bgPr>
-        <a:solidFill>
-          <a:srgbClr val="FFFFFF"/>
-        </a:solidFill>
-        <a:effectLst/>
-      </p:bgPr>
-    </p:bg>
-    <p:spTree>
-      <p:nvGrpSpPr>
-        <p:cNvPr id="1" name=""/>
-        <p:cNvGrpSpPr/>
-        <p:nvPr/>
-      </p:nvGrpSpPr>
-      <p:grpSpPr/>
-      <p:sp>
-        <p:nvSpPr>
-          <p:cNvPr id="2" name="TextBox 1"/>
-          <p:cNvSpPr txBox="1"/>
-          <p:nvPr/>
-        </p:nvSpPr>
-        <p:spPr>
-          <a:xfrm>
-            <a:off x="530352" y="237744"/>
-            <a:ext cx="4114800" cy="228600"/>
-          </a:xfrm>
-          <a:prstGeom prst="rect">
-            <a:avLst/>
-          </a:prstGeom>
-          <a:noFill/>
-        </p:spPr>
-        <p:txBody>
-          <a:bodyPr wrap="none" lIns="0" rIns="0" tIns="0" bIns="0" anchor="t">
-            <a:spAutoFit/>
-          </a:bodyPr>
-          <a:lstStyle/>
-          <a:p>
-            <a:pPr algn="l"/>
-            <a:r>
-              <a:rPr sz="1150" b="1">
-                <a:solidFill>
-                  <a:srgbClr val="117865"/>
-                </a:solidFill>
-                <a:latin typeface="Segoe UI"/>
-              </a:rPr>
-              <a:t>PHYSICAL DATA MODEL</a:t>
-            </a:r>
-          </a:p>
-        </p:txBody>
-      </p:sp>
-      <p:sp>
-        <p:nvSpPr>
-          <p:cNvPr id="3" name="TextBox 2"/>
-          <p:cNvSpPr txBox="1"/>
-          <p:nvPr/>
-        </p:nvSpPr>
-        <p:spPr>
-          <a:xfrm>
-            <a:off x="530352" y="548640"/>
-            <a:ext cx="11018520" cy="841248"/>
-          </a:xfrm>
-          <a:prstGeom prst="rect">
-            <a:avLst/>
-          </a:prstGeom>
-          <a:noFill/>
-        </p:spPr>
-        <p:txBody>
-          <a:bodyPr wrap="none" lIns="0" rIns="0" tIns="0" bIns="0" anchor="t">
-            <a:spAutoFit/>
-          </a:bodyPr>
-          <a:lstStyle/>
-          <a:p>
-            <a:pPr algn="l"/>
-            <a:r>
-              <a:rPr sz="2750" b="1">
-                <a:solidFill>
-                  <a:srgbClr val="242424"/>
-                </a:solidFill>
-                <a:latin typeface="Segoe UI"/>
-              </a:rPr>
-              <a:t>The snapshot catalog becomes concrete MSSQL tables.</a:t>
-            </a:r>
-          </a:p>
-        </p:txBody>
-      </p:sp>
-      <p:sp>
-        <p:nvSpPr>
-          <p:cNvPr id="4" name="Rounded Rectangle 3"/>
-          <p:cNvSpPr/>
-          <p:nvPr/>
-        </p:nvSpPr>
-        <p:spPr>
-          <a:xfrm>
-            <a:off x="411480" y="1472184"/>
-            <a:ext cx="7726679" cy="4443984"/>
-          </a:xfrm>
-          <a:prstGeom prst="roundRect">
-            <a:avLst/>
-          </a:prstGeom>
-          <a:solidFill>
-            <a:srgbClr val="FFFFFF"/>
-          </a:solidFill>
-          <a:ln>
-            <a:solidFill>
-              <a:srgbClr val="E0E0E0"/>
-            </a:solidFill>
-          </a:ln>
-        </p:spPr>
-        <p:style>
-          <a:lnRef idx="1">
-            <a:schemeClr val="accent1"/>
-          </a:lnRef>
-          <a:fillRef idx="3">
-            <a:schemeClr val="accent1"/>
-          </a:fillRef>
-          <a:effectRef idx="2">
-            <a:schemeClr val="accent1"/>
-          </a:effectRef>
-          <a:fontRef idx="minor">
-            <a:schemeClr val="lt1"/>
-          </a:fontRef>
-        </p:style>
-        <p:txBody>
-          <a:bodyPr rtlCol="0" anchor="ctr"/>
-          <a:lstStyle/>
-          <a:p>
-            <a:pPr algn="ctr"/>
-          </a:p>
-        </p:txBody>
-      </p:sp>
-      <p:pic>
-        <p:nvPicPr>
-          <p:cNvPr id="5" name="Picture 4" descr="02-mpd-catalog.png"/>
-          <p:cNvPicPr>
-            <a:picLocks noChangeAspect="1"/>
-          </p:cNvPicPr>
-          <p:nvPr/>
-        </p:nvPicPr>
-        <p:blipFill>
-          <a:blip r:embed="rId2"/>
-          <a:stretch>
-            <a:fillRect/>
-          </a:stretch>
-        </p:blipFill>
-        <p:spPr>
-          <a:xfrm>
-            <a:off x="1404496" y="1554480"/>
-            <a:ext cx="5740647" cy="4279392"/>
-          </a:xfrm>
-          <a:prstGeom prst="rect">
-            <a:avLst/>
-          </a:prstGeom>
-        </p:spPr>
-      </p:pic>
-      <p:sp>
-        <p:nvSpPr>
-          <p:cNvPr id="6" name="TextBox 5"/>
-          <p:cNvSpPr txBox="1"/>
-          <p:nvPr/>
-        </p:nvSpPr>
-        <p:spPr>
-          <a:xfrm>
-            <a:off x="8357616" y="1673352"/>
-            <a:ext cx="3227832" cy="4069080"/>
-          </a:xfrm>
-          <a:prstGeom prst="rect">
-            <a:avLst/>
-          </a:prstGeom>
-          <a:noFill/>
-        </p:spPr>
-        <p:txBody>
-          <a:bodyPr wrap="square" lIns="36576" rIns="0" tIns="0" bIns="0">
-            <a:spAutoFit/>
-          </a:bodyPr>
-          <a:lstStyle/>
-          <a:p>
-            <a:pPr>
-              <a:buChar char="•"/>
-              <a:spcAft>
-                <a:spcPts val="1800"/>
-              </a:spcAft>
-              <a:defRPr sz="1550">
-                <a:solidFill>
-                  <a:srgbClr val="242424"/>
-                </a:solidFill>
-                <a:latin typeface="Segoe UI"/>
-              </a:defRPr>
-            </a:pPr>
-            <a:r>
-              <a:t>Entity names become plural dbo table names.</a:t>
-            </a:r>
-          </a:p>
-          <a:p>
-            <a:pPr>
-              <a:buChar char="•"/>
-              <a:spcAft>
-                <a:spcPts val="1800"/>
-              </a:spcAft>
-              <a:defRPr sz="1550">
-                <a:solidFill>
-                  <a:srgbClr val="242424"/>
-                </a:solidFill>
-                <a:latin typeface="Segoe UI"/>
-              </a:defRPr>
-            </a:pPr>
-            <a:r>
-              <a:t>id becomes a UNIQUEIDENTIFIER primary key; optional fields become NULL.</a:t>
-            </a:r>
-          </a:p>
-          <a:p>
-            <a:pPr>
-              <a:buChar char="•"/>
-              <a:spcAft>
-                <a:spcPts val="1800"/>
-              </a:spcAft>
-              <a:defRPr sz="1550">
-                <a:solidFill>
-                  <a:srgbClr val="242424"/>
-                </a:solidFill>
-                <a:latin typeface="Segoe UI"/>
-              </a:defRPr>
-            </a:pPr>
-            <a:r>
-              <a:t>Text, date, boolean and set decorators become NVARCHAR, DATETIME2, BIT and CHECK constraints.</a:t>
-            </a:r>
-          </a:p>
-        </p:txBody>
-      </p:sp>
-      <p:sp>
-        <p:nvSpPr>
-          <p:cNvPr id="7" name="TextBox 6"/>
-          <p:cNvSpPr txBox="1"/>
-          <p:nvPr/>
-        </p:nvSpPr>
-        <p:spPr>
-          <a:xfrm>
-            <a:off x="530352" y="6428232"/>
-            <a:ext cx="10195560" cy="182880"/>
-          </a:xfrm>
-          <a:prstGeom prst="rect">
-            <a:avLst/>
-          </a:prstGeom>
-          <a:noFill/>
-        </p:spPr>
-        <p:txBody>
-          <a:bodyPr wrap="none" lIns="0" rIns="0" tIns="0" bIns="0" anchor="t">
-            <a:spAutoFit/>
-          </a:bodyPr>
-          <a:lstStyle/>
-          <a:p>
-            <a:pPr algn="l"/>
-            <a:r>
-              <a:rPr sz="1050" b="0">
-                <a:solidFill>
-                  <a:srgbClr val="616161"/>
-                </a:solidFill>
-                <a:latin typeface="Segoe UI"/>
-              </a:rPr>
-              <a:t>Source: rayfin/data/*.ts + @microsoft/rayfin-core 1.33.1 MSSQL mapper</a:t>
-            </a:r>
-          </a:p>
-        </p:txBody>
-      </p:sp>
-      <p:sp>
-        <p:nvSpPr>
-          <p:cNvPr id="8" name="TextBox 7"/>
-          <p:cNvSpPr txBox="1"/>
-          <p:nvPr/>
-        </p:nvSpPr>
-        <p:spPr>
-          <a:xfrm>
-            <a:off x="11109960" y="6428232"/>
-            <a:ext cx="502920" cy="182880"/>
-          </a:xfrm>
-          <a:prstGeom prst="rect">
-            <a:avLst/>
-          </a:prstGeom>
-          <a:noFill/>
-        </p:spPr>
-        <p:txBody>
-          <a:bodyPr wrap="none" lIns="0" rIns="0" tIns="0" bIns="0" anchor="t">
-            <a:spAutoFit/>
-          </a:bodyPr>
-          <a:lstStyle/>
-          <a:p>
-            <a:pPr algn="r"/>
-            <a:r>
-              <a:rPr sz="1050" b="0">
-                <a:solidFill>
-                  <a:srgbClr val="616161"/>
-                </a:solidFill>
-                <a:latin typeface="Segoe UI"/>
-              </a:rPr>
-              <a:t>9</a:t>
-            </a:r>
           </a:p>
         </p:txBody>
       </p:sp>
@@ -3674,7 +3917,7 @@
         <p:spPr>
           <a:xfrm>
             <a:off x="530352" y="237744"/>
-            <a:ext cx="4114800" cy="228600"/>
+            <a:ext cx="4389120" cy="228600"/>
           </a:xfrm>
           <a:prstGeom prst="rect">
             <a:avLst/>
@@ -3709,7 +3952,7 @@
         <p:spPr>
           <a:xfrm>
             <a:off x="530352" y="548640"/>
-            <a:ext cx="11018520" cy="841248"/>
+            <a:ext cx="11018520" cy="786384"/>
           </a:xfrm>
           <a:prstGeom prst="rect">
             <a:avLst/>
@@ -3724,65 +3967,20 @@
           <a:p>
             <a:pPr algn="l"/>
             <a:r>
-              <a:rPr sz="2750" b="1">
+              <a:rPr sz="2700" b="1">
                 <a:solidFill>
                   <a:srgbClr val="242424"/>
                 </a:solidFill>
                 <a:latin typeface="Segoe UI"/>
               </a:rPr>
-              <a:t>Access and audit use the same physical SQL rules.</a:t>
-            </a:r>
-          </a:p>
-        </p:txBody>
-      </p:sp>
-      <p:sp>
-        <p:nvSpPr>
-          <p:cNvPr id="4" name="Rounded Rectangle 3"/>
-          <p:cNvSpPr/>
-          <p:nvPr/>
-        </p:nvSpPr>
-        <p:spPr>
-          <a:xfrm>
-            <a:off x="411480" y="1472184"/>
-            <a:ext cx="7726679" cy="4443984"/>
-          </a:xfrm>
-          <a:prstGeom prst="roundRect">
-            <a:avLst/>
-          </a:prstGeom>
-          <a:solidFill>
-            <a:srgbClr val="FFFFFF"/>
-          </a:solidFill>
-          <a:ln>
-            <a:solidFill>
-              <a:srgbClr val="E0E0E0"/>
-            </a:solidFill>
-          </a:ln>
-        </p:spPr>
-        <p:style>
-          <a:lnRef idx="1">
-            <a:schemeClr val="accent1"/>
-          </a:lnRef>
-          <a:fillRef idx="3">
-            <a:schemeClr val="accent1"/>
-          </a:fillRef>
-          <a:effectRef idx="2">
-            <a:schemeClr val="accent1"/>
-          </a:effectRef>
-          <a:fontRef idx="minor">
-            <a:schemeClr val="lt1"/>
-          </a:fontRef>
-        </p:style>
-        <p:txBody>
-          <a:bodyPr rtlCol="0" anchor="ctr"/>
-          <a:lstStyle/>
-          <a:p>
-            <a:pPr algn="ctr"/>
+              <a:t>The full MPD shows all 15 MSSQL tables and their logical links.</a:t>
+            </a:r>
           </a:p>
         </p:txBody>
       </p:sp>
       <p:pic>
         <p:nvPicPr>
-          <p:cNvPr id="5" name="Picture 4" descr="03-mpd-access.png"/>
+          <p:cNvPr id="4" name="Picture 3" descr="04-mpd-full.png"/>
           <p:cNvPicPr>
             <a:picLocks noChangeAspect="1"/>
           </p:cNvPicPr>
@@ -3796,8 +3994,8 @@
         </p:blipFill>
         <p:spPr>
           <a:xfrm>
-            <a:off x="1162534" y="1554480"/>
-            <a:ext cx="6224570" cy="4279392"/>
+            <a:off x="384048" y="1794597"/>
+            <a:ext cx="11420856" cy="3625421"/>
           </a:xfrm>
           <a:prstGeom prst="rect">
             <a:avLst/>
@@ -3806,88 +4004,14 @@
       </p:pic>
       <p:sp>
         <p:nvSpPr>
-          <p:cNvPr id="6" name="TextBox 5"/>
+          <p:cNvPr id="5" name="TextBox 4"/>
           <p:cNvSpPr txBox="1"/>
           <p:nvPr/>
         </p:nvSpPr>
         <p:spPr>
           <a:xfrm>
-            <a:off x="8357616" y="1673352"/>
-            <a:ext cx="3227832" cy="4069080"/>
-          </a:xfrm>
-          <a:prstGeom prst="rect">
-            <a:avLst/>
-          </a:prstGeom>
-          <a:noFill/>
-        </p:spPr>
-        <p:txBody>
-          <a:bodyPr wrap="square" lIns="36576" rIns="0" tIns="0" bIns="0">
-            <a:spAutoFit/>
-          </a:bodyPr>
-          <a:lstStyle/>
-          <a:p>
-            <a:pPr>
-              <a:buChar char="•"/>
-              <a:spcAft>
-                <a:spcPts val="1800"/>
-              </a:spcAft>
-              <a:defRPr sz="1550">
-                <a:solidFill>
-                  <a:srgbClr val="242424"/>
-                </a:solidFill>
-                <a:latin typeface="Segoe UI"/>
-              </a:defRPr>
-            </a:pPr>
-            <a:r>
-              <a:t>workspace_id and snapshotId scope each table.</a:t>
-            </a:r>
-          </a:p>
-          <a:p>
-            <a:pPr>
-              <a:buChar char="•"/>
-              <a:spcAft>
-                <a:spcPts val="1800"/>
-              </a:spcAft>
-              <a:defRPr sz="1550">
-                <a:solidFill>
-                  <a:srgbClr val="242424"/>
-                </a:solidFill>
-                <a:latin typeface="Segoe UI"/>
-              </a:defRPr>
-            </a:pPr>
-            <a:r>
-              <a:t>principalRef and itemFabricId remain NVARCHAR logical references.</a:t>
-            </a:r>
-          </a:p>
-          <a:p>
-            <a:pPr>
-              <a:buChar char="•"/>
-              <a:spcAft>
-                <a:spcPts val="1800"/>
-              </a:spcAft>
-              <a:defRPr sz="1550">
-                <a:solidFill>
-                  <a:srgbClr val="242424"/>
-                </a:solidFill>
-                <a:latin typeface="Segoe UI"/>
-              </a:defRPr>
-            </a:pPr>
-            <a:r>
-              <a:t>No SQL foreign keys are generated because Atlas declares no @one or @many properties.</a:t>
-            </a:r>
-          </a:p>
-        </p:txBody>
-      </p:sp>
-      <p:sp>
-        <p:nvSpPr>
-          <p:cNvPr id="7" name="TextBox 6"/>
-          <p:cNvSpPr txBox="1"/>
-          <p:nvPr/>
-        </p:nvSpPr>
-        <p:spPr>
-          <a:xfrm>
-            <a:off x="530352" y="6428232"/>
-            <a:ext cx="10195560" cy="182880"/>
+            <a:off x="685800" y="5925312"/>
+            <a:ext cx="10826496" cy="256032"/>
           </a:xfrm>
           <a:prstGeom prst="rect">
             <a:avLst/>
@@ -3900,29 +4024,29 @@
           </a:bodyPr>
           <a:lstStyle/>
           <a:p>
-            <a:pPr algn="l"/>
-            <a:r>
-              <a:rPr sz="1050" b="0">
-                <a:solidFill>
-                  <a:srgbClr val="616161"/>
+            <a:pPr algn="ctr"/>
+            <a:r>
+              <a:rPr sz="1270" b="1">
+                <a:solidFill>
+                  <a:srgbClr val="117865"/>
                 </a:solidFill>
                 <a:latin typeface="Segoe UI"/>
               </a:rPr>
-              <a:t>Source: rayfin/data/*.ts + Rayfin schema analyzer</a:t>
-            </a:r>
-          </a:p>
-        </p:txBody>
-      </p:sp>
-      <p:sp>
-        <p:nvSpPr>
-          <p:cNvPr id="8" name="TextBox 7"/>
+              <a:t>Rayfin MSSQL mapping 1.33.1 · UNIQUEIDENTIFIER primary keys · NVARCHAR logical references · no generated FK constraints</a:t>
+            </a:r>
+          </a:p>
+        </p:txBody>
+      </p:sp>
+      <p:sp>
+        <p:nvSpPr>
+          <p:cNvPr id="6" name="TextBox 5"/>
           <p:cNvSpPr txBox="1"/>
           <p:nvPr/>
         </p:nvSpPr>
         <p:spPr>
           <a:xfrm>
-            <a:off x="11109960" y="6428232"/>
-            <a:ext cx="502920" cy="182880"/>
+            <a:off x="530352" y="6428232"/>
+            <a:ext cx="10195560" cy="182880"/>
           </a:xfrm>
           <a:prstGeom prst="rect">
             <a:avLst/>
@@ -3935,6 +4059,41 @@
           </a:bodyPr>
           <a:lstStyle/>
           <a:p>
+            <a:pPr algn="l"/>
+            <a:r>
+              <a:rPr sz="1050" b="0">
+                <a:solidFill>
+                  <a:srgbClr val="616161"/>
+                </a:solidFill>
+                <a:latin typeface="Segoe UI"/>
+              </a:rPr>
+              <a:t>Source: rayfin/data/*.ts + @microsoft/rayfin-core 1.33.1 MSSQL mapper</a:t>
+            </a:r>
+          </a:p>
+        </p:txBody>
+      </p:sp>
+      <p:sp>
+        <p:nvSpPr>
+          <p:cNvPr id="7" name="TextBox 6"/>
+          <p:cNvSpPr txBox="1"/>
+          <p:nvPr/>
+        </p:nvSpPr>
+        <p:spPr>
+          <a:xfrm>
+            <a:off x="11109960" y="6428232"/>
+            <a:ext cx="502920" cy="182880"/>
+          </a:xfrm>
+          <a:prstGeom prst="rect">
+            <a:avLst/>
+          </a:prstGeom>
+          <a:noFill/>
+        </p:spPr>
+        <p:txBody>
+          <a:bodyPr wrap="none" lIns="0" rIns="0" tIns="0" bIns="0" anchor="t">
+            <a:spAutoFit/>
+          </a:bodyPr>
+          <a:lstStyle/>
+          <a:p>
             <a:pPr algn="r"/>
             <a:r>
               <a:rPr sz="1050" b="0">
@@ -3943,7 +4102,7 @@
                 </a:solidFill>
                 <a:latin typeface="Segoe UI"/>
               </a:rPr>
-              <a:t>10</a:t>
+              <a:t>9</a:t>
             </a:r>
           </a:p>
         </p:txBody>
@@ -8382,14 +8541,15 @@
 </p:sld>
 </file>
 
-<file path=ppt/slides/slide9.xml><?xml version="1.0" encoding="utf-8"?>
-<p:sld xmlns:a="http://schemas.openxmlformats.org/drawingml/2006/main" xmlns:r="http://schemas.openxmlformats.org/officeDocument/2006/relationships" xmlns:p="http://schemas.openxmlformats.org/presentationml/2006/main">
-  <p:cSld name="Slide 9">
+<file path=ppt/slides/slide8.xml><?xml version="1.0" encoding="utf-8"?>
+<p:sld xmlns:a="http://schemas.openxmlformats.org/drawingml/2006/main" xmlns:p="http://schemas.openxmlformats.org/presentationml/2006/main" xmlns:r="http://schemas.openxmlformats.org/officeDocument/2006/relationships">
+  <p:cSld>
     <p:bg>
       <p:bgPr>
         <a:solidFill>
           <a:srgbClr val="FFFFFF"/>
         </a:solidFill>
+        <a:effectLst/>
       </p:bgPr>
     </p:bg>
     <p:spTree>
@@ -8398,879 +8558,259 @@
         <p:cNvGrpSpPr/>
         <p:nvPr/>
       </p:nvGrpSpPr>
-      <p:grpSpPr>
-        <a:xfrm>
-          <a:off x="0" y="0"/>
-          <a:ext cx="0" cy="0"/>
-          <a:chOff x="0" y="0"/>
-          <a:chExt cx="0" cy="0"/>
-        </a:xfrm>
-      </p:grpSpPr>
-      <p:sp>
-        <p:nvSpPr>
-          <p:cNvPr id="2" name="Text 0"/>
-          <p:cNvSpPr/>
+      <p:grpSpPr/>
+      <p:sp>
+        <p:nvSpPr>
+          <p:cNvPr id="2" name="TextBox 1"/>
+          <p:cNvSpPr txBox="1"/>
           <p:nvPr/>
         </p:nvSpPr>
         <p:spPr>
           <a:xfrm>
             <a:off x="530352" y="237744"/>
-            <a:ext cx="4206240" cy="219456"/>
-          </a:xfrm>
-          <a:prstGeom prst="rect">
-            <a:avLst/>
-          </a:prstGeom>
-          <a:noFill/>
-          <a:ln/>
-        </p:spPr>
-        <p:txBody>
-          <a:bodyPr wrap="square" lIns="0" tIns="0" rIns="0" bIns="0" rtlCol="0" anchor="t"/>
-          <a:lstStyle/>
-          <a:p>
-            <a:pPr algn="l" indent="0" marL="0">
-              <a:buNone/>
-            </a:pPr>
-            <a:r>
-              <a:rPr lang="en-GB" altLang="en-US" sz="1150" b="1" dirty="0">
+            <a:ext cx="4114800" cy="228600"/>
+          </a:xfrm>
+          <a:prstGeom prst="rect">
+            <a:avLst/>
+          </a:prstGeom>
+          <a:noFill/>
+        </p:spPr>
+        <p:txBody>
+          <a:bodyPr wrap="none" lIns="0" rIns="0" tIns="0" bIns="0" anchor="t">
+            <a:spAutoFit/>
+          </a:bodyPr>
+          <a:lstStyle/>
+          <a:p>
+            <a:pPr algn="l"/>
+            <a:r>
+              <a:rPr sz="1150" b="1">
                 <a:solidFill>
                   <a:srgbClr val="117865"/>
                 </a:solidFill>
-                <a:latin typeface="Segoe UI" pitchFamily="34" charset="0"/>
-                <a:ea typeface="Segoe UI" pitchFamily="34" charset="-122"/>
-                <a:cs typeface="Segoe UI" pitchFamily="34" charset="-120"/>
-              </a:rPr>
-              <a:t>RAYFIN SCHEMA GENERATION</a:t>
-            </a:r>
-            <a:endParaRPr lang="en-GB" sz="1150" dirty="0"/>
-          </a:p>
-        </p:txBody>
-      </p:sp>
-      <p:sp>
-        <p:nvSpPr>
-          <p:cNvPr id="3" name="Text 1"/>
-          <p:cNvSpPr/>
+                <a:latin typeface="Segoe UI"/>
+              </a:rPr>
+              <a:t>UML ENTITY MODEL</a:t>
+            </a:r>
+          </a:p>
+        </p:txBody>
+      </p:sp>
+      <p:sp>
+        <p:nvSpPr>
+          <p:cNvPr id="3" name="TextBox 2"/>
+          <p:cNvSpPr txBox="1"/>
           <p:nvPr/>
         </p:nvSpPr>
         <p:spPr>
           <a:xfrm>
             <a:off x="530352" y="548640"/>
-            <a:ext cx="10972800" cy="932688"/>
-          </a:xfrm>
-          <a:prstGeom prst="rect">
-            <a:avLst/>
-          </a:prstGeom>
-          <a:noFill/>
-          <a:ln/>
-        </p:spPr>
-        <p:txBody>
-          <a:bodyPr wrap="square" lIns="0" tIns="0" rIns="0" bIns="0" rtlCol="0" anchor="t"/>
-          <a:lstStyle/>
-          <a:p>
-            <a:pPr algn="l" indent="0" marL="0">
-              <a:buNone/>
-            </a:pPr>
-            <a:r>
-              <a:rPr lang="en-GB" altLang="en-US" sz="2750" b="1" dirty="0">
+            <a:ext cx="11018520" cy="841248"/>
+          </a:xfrm>
+          <a:prstGeom prst="rect">
+            <a:avLst/>
+          </a:prstGeom>
+          <a:noFill/>
+        </p:spPr>
+        <p:txBody>
+          <a:bodyPr wrap="none" lIns="0" rIns="0" tIns="0" bIns="0" anchor="t">
+            <a:spAutoFit/>
+          </a:bodyPr>
+          <a:lstStyle/>
+          <a:p>
+            <a:pPr algn="l"/>
+            <a:r>
+              <a:rPr sz="2750" b="1">
                 <a:solidFill>
                   <a:srgbClr val="242424"/>
                 </a:solidFill>
-                <a:latin typeface="Segoe UI" pitchFamily="34" charset="0"/>
-                <a:ea typeface="Segoe UI" pitchFamily="34" charset="-122"/>
-                <a:cs typeface="Segoe UI" pitchFamily="34" charset="-120"/>
-              </a:rPr>
-              <a:t>Rayfin turns decorated TypeScript classes into the Fabric SQL data model.</a:t>
-            </a:r>
-            <a:endParaRPr lang="en-GB" sz="2750" dirty="0"/>
-          </a:p>
-        </p:txBody>
-      </p:sp>
-      <p:sp>
-        <p:nvSpPr>
-          <p:cNvPr id="4" name="Shape 2"/>
-          <p:cNvSpPr/>
-          <p:nvPr/>
-        </p:nvSpPr>
-        <p:spPr>
-          <a:xfrm>
-            <a:off x="690829" y="1764198"/>
-            <a:ext cx="1926069" cy="892569"/>
+                <a:latin typeface="Segoe UI"/>
+              </a:rPr>
+              <a:t>The UML model shows entity classes and logical associations.</a:t>
+            </a:r>
+          </a:p>
+        </p:txBody>
+      </p:sp>
+      <p:sp>
+        <p:nvSpPr>
+          <p:cNvPr id="4" name="Rounded Rectangle 3"/>
+          <p:cNvSpPr/>
+          <p:nvPr/>
+        </p:nvSpPr>
+        <p:spPr>
+          <a:xfrm>
+            <a:off x="411480" y="1472184"/>
+            <a:ext cx="7726679" cy="4443984"/>
           </a:xfrm>
           <a:prstGeom prst="roundRect">
-            <a:avLst>
-              <a:gd name="adj" fmla="val 8421"/>
-            </a:avLst>
+            <a:avLst/>
           </a:prstGeom>
           <a:solidFill>
-            <a:srgbClr val="E3F7EF"/>
+            <a:srgbClr val="FFFFFF"/>
           </a:solidFill>
-          <a:ln w="15240">
+          <a:ln>
             <a:solidFill>
-              <a:srgbClr val="117865"/>
+              <a:srgbClr val="E0E0E0"/>
             </a:solidFill>
-            <a:prstDash val="solid"/>
           </a:ln>
         </p:spPr>
-        <p:txBody>
-          <a:bodyPr/>
-          <a:p/>
-        </p:txBody>
-      </p:sp>
-      <p:sp>
-        <p:nvSpPr>
-          <p:cNvPr id="5" name="Text 3"/>
-          <p:cNvSpPr/>
-          <p:nvPr/>
-        </p:nvSpPr>
-        <p:spPr>
-          <a:xfrm>
-            <a:off x="841157" y="1858152"/>
-            <a:ext cx="1625415" cy="507355"/>
-          </a:xfrm>
-          <a:prstGeom prst="rect">
-            <a:avLst/>
-          </a:prstGeom>
-          <a:noFill/>
-          <a:ln/>
-        </p:spPr>
-        <p:txBody>
-          <a:bodyPr wrap="square" lIns="0" tIns="0" rIns="0" bIns="0" rtlCol="0" anchor="t"/>
-          <a:lstStyle/>
-          <a:p>
-            <a:pPr algn="ctr" indent="0" marL="0">
-              <a:buNone/>
-            </a:pPr>
-            <a:r>
-              <a:rPr lang="en-GB" altLang="en-US" sz="1562" b="1" dirty="0">
-                <a:solidFill>
-                  <a:srgbClr val="0C695A"/>
-                </a:solidFill>
-                <a:latin typeface="Segoe UI" pitchFamily="34" charset="0"/>
-                <a:ea typeface="Segoe UI" pitchFamily="34" charset="-122"/>
-                <a:cs typeface="Segoe UI" pitchFamily="34" charset="-120"/>
-              </a:rPr>
-              <a:t>TypeScript</a:t>
-            </a:r>
-            <a:endParaRPr lang="en-GB" sz="1562" dirty="0"/>
-          </a:p>
-          <a:p>
-            <a:pPr algn="ctr" indent="0" marL="0">
-              <a:buNone/>
-            </a:pPr>
-            <a:r>
-              <a:rPr lang="en-GB" altLang="en-US" sz="1562" b="1" dirty="0">
-                <a:solidFill>
-                  <a:srgbClr val="0C695A"/>
-                </a:solidFill>
-                <a:latin typeface="Segoe UI" pitchFamily="34" charset="0"/>
-                <a:ea typeface="Segoe UI" pitchFamily="34" charset="-122"/>
-                <a:cs typeface="Segoe UI" pitchFamily="34" charset="-120"/>
-              </a:rPr>
-              <a:t>entities</a:t>
-            </a:r>
-            <a:endParaRPr lang="en-GB" sz="1562" dirty="0"/>
-          </a:p>
-        </p:txBody>
-      </p:sp>
-      <p:sp>
-        <p:nvSpPr>
-          <p:cNvPr id="6" name="Text 4"/>
-          <p:cNvSpPr/>
-          <p:nvPr/>
-        </p:nvSpPr>
-        <p:spPr>
-          <a:xfrm>
-            <a:off x="841157" y="2384298"/>
-            <a:ext cx="1625415" cy="310050"/>
-          </a:xfrm>
-          <a:prstGeom prst="rect">
-            <a:avLst/>
-          </a:prstGeom>
-          <a:noFill/>
-          <a:ln/>
-        </p:spPr>
-        <p:txBody>
-          <a:bodyPr wrap="square" lIns="0" tIns="0" rIns="0" bIns="0" rtlCol="0" anchor="t"/>
-          <a:lstStyle/>
-          <a:p>
-            <a:pPr algn="ctr" indent="0" marL="0">
-              <a:buNone/>
-            </a:pPr>
-            <a:r>
-              <a:rPr lang="en-GB" altLang="en-US" sz="1151" dirty="0">
+        <p:style>
+          <a:lnRef idx="1">
+            <a:schemeClr val="accent1"/>
+          </a:lnRef>
+          <a:fillRef idx="3">
+            <a:schemeClr val="accent1"/>
+          </a:fillRef>
+          <a:effectRef idx="2">
+            <a:schemeClr val="accent1"/>
+          </a:effectRef>
+          <a:fontRef idx="minor">
+            <a:schemeClr val="lt1"/>
+          </a:fontRef>
+        </p:style>
+        <p:txBody>
+          <a:bodyPr rtlCol="0" anchor="ctr"/>
+          <a:lstStyle/>
+          <a:p>
+            <a:pPr algn="ctr"/>
+          </a:p>
+        </p:txBody>
+      </p:sp>
+      <p:pic>
+        <p:nvPicPr>
+          <p:cNvPr id="5" name="Picture 4" descr="01-uml.png"/>
+          <p:cNvPicPr>
+            <a:picLocks noChangeAspect="1"/>
+          </p:cNvPicPr>
+          <p:nvPr/>
+        </p:nvPicPr>
+        <p:blipFill>
+          <a:blip r:embed="rId2"/>
+          <a:stretch>
+            <a:fillRect/>
+          </a:stretch>
+        </p:blipFill>
+        <p:spPr>
+          <a:xfrm>
+            <a:off x="1820732" y="1554480"/>
+            <a:ext cx="4908175" cy="4279392"/>
+          </a:xfrm>
+          <a:prstGeom prst="rect">
+            <a:avLst/>
+          </a:prstGeom>
+        </p:spPr>
+      </p:pic>
+      <p:sp>
+        <p:nvSpPr>
+          <p:cNvPr id="6" name="TextBox 5"/>
+          <p:cNvSpPr txBox="1"/>
+          <p:nvPr/>
+        </p:nvSpPr>
+        <p:spPr>
+          <a:xfrm>
+            <a:off x="8357616" y="1673352"/>
+            <a:ext cx="3227832" cy="4069080"/>
+          </a:xfrm>
+          <a:prstGeom prst="rect">
+            <a:avLst/>
+          </a:prstGeom>
+          <a:noFill/>
+        </p:spPr>
+        <p:txBody>
+          <a:bodyPr wrap="square" lIns="36576" rIns="0" tIns="0" bIns="0">
+            <a:spAutoFit/>
+          </a:bodyPr>
+          <a:lstStyle/>
+          <a:p>
+            <a:pPr>
+              <a:buChar char="•"/>
+              <a:spcAft>
+                <a:spcPts val="1800"/>
+              </a:spcAft>
+              <a:defRPr sz="1550">
+                <a:solidFill>
+                  <a:srgbClr val="242424"/>
+                </a:solidFill>
+                <a:latin typeface="Segoe UI"/>
+              </a:defRPr>
+            </a:pPr>
+            <a:r>
+              <a:t>Selected properties mirror the TypeScript entity classes.</a:t>
+            </a:r>
+          </a:p>
+          <a:p>
+            <a:pPr>
+              <a:buChar char="•"/>
+              <a:spcAft>
+                <a:spcPts val="1800"/>
+              </a:spcAft>
+              <a:defRPr sz="1550">
+                <a:solidFill>
+                  <a:srgbClr val="242424"/>
+                </a:solidFill>
+                <a:latin typeface="Segoe UI"/>
+              </a:defRPr>
+            </a:pPr>
+            <a:r>
+              <a:t>Workspace publishes a snapshot; FabricItem anchors item-level facts.</a:t>
+            </a:r>
+          </a:p>
+          <a:p>
+            <a:pPr>
+              <a:buChar char="•"/>
+              <a:spcAft>
+                <a:spcPts val="1800"/>
+              </a:spcAft>
+              <a:defRPr sz="1550">
+                <a:solidFill>
+                  <a:srgbClr val="242424"/>
+                </a:solidFill>
+                <a:latin typeface="Segoe UI"/>
+              </a:defRPr>
+            </a:pPr>
+            <a:r>
+              <a:t>Lines are logical associations, not Rayfin navigation decorators.</a:t>
+            </a:r>
+          </a:p>
+        </p:txBody>
+      </p:sp>
+      <p:sp>
+        <p:nvSpPr>
+          <p:cNvPr id="7" name="TextBox 6"/>
+          <p:cNvSpPr txBox="1"/>
+          <p:nvPr/>
+        </p:nvSpPr>
+        <p:spPr>
+          <a:xfrm>
+            <a:off x="530352" y="6428232"/>
+            <a:ext cx="10195560" cy="182880"/>
+          </a:xfrm>
+          <a:prstGeom prst="rect">
+            <a:avLst/>
+          </a:prstGeom>
+          <a:noFill/>
+        </p:spPr>
+        <p:txBody>
+          <a:bodyPr wrap="none" lIns="0" rIns="0" tIns="0" bIns="0" anchor="t">
+            <a:spAutoFit/>
+          </a:bodyPr>
+          <a:lstStyle/>
+          <a:p>
+            <a:pPr algn="l"/>
+            <a:r>
+              <a:rPr sz="1050" b="0">
                 <a:solidFill>
                   <a:srgbClr val="616161"/>
                 </a:solidFill>
-                <a:latin typeface="Segoe UI" pitchFamily="34" charset="0"/>
-                <a:ea typeface="Segoe UI" pitchFamily="34" charset="-122"/>
-                <a:cs typeface="Segoe UI" pitchFamily="34" charset="-120"/>
-              </a:rPr>
-              <a:t>@entity · fields · policies</a:t>
-            </a:r>
-            <a:endParaRPr lang="en-GB" sz="1151" dirty="0"/>
-          </a:p>
-        </p:txBody>
-      </p:sp>
-      <p:sp>
-        <p:nvSpPr>
-          <p:cNvPr id="7" name="Shape 5"/>
-          <p:cNvSpPr/>
-          <p:nvPr/>
-        </p:nvSpPr>
-        <p:spPr>
-          <a:xfrm>
-            <a:off x="2673271" y="2215180"/>
-            <a:ext cx="488564" cy="0"/>
-          </a:xfrm>
-          <a:prstGeom prst="line">
-            <a:avLst/>
-          </a:prstGeom>
-          <a:noFill/>
-          <a:ln w="23489">
-            <a:solidFill>
-              <a:srgbClr val="117865"/>
-            </a:solidFill>
-            <a:prstDash val="solid"/>
-            <a:tailEnd type="triangle"/>
-          </a:ln>
-        </p:spPr>
-        <p:txBody>
-          <a:bodyPr/>
-          <a:p/>
-        </p:txBody>
-      </p:sp>
-      <p:sp>
-        <p:nvSpPr>
-          <p:cNvPr id="8" name="Shape 6"/>
-          <p:cNvSpPr/>
-          <p:nvPr/>
-        </p:nvSpPr>
-        <p:spPr>
-          <a:xfrm>
-            <a:off x="3227603" y="1764198"/>
-            <a:ext cx="1362342" cy="892569"/>
-          </a:xfrm>
-          <a:prstGeom prst="roundRect">
-            <a:avLst>
-              <a:gd name="adj" fmla="val 8421"/>
-            </a:avLst>
-          </a:prstGeom>
-          <a:solidFill>
-            <a:srgbClr val="E3F7EF"/>
-          </a:solidFill>
-          <a:ln w="15240">
-            <a:solidFill>
-              <a:srgbClr val="117865"/>
-            </a:solidFill>
-            <a:prstDash val="solid"/>
-          </a:ln>
-        </p:spPr>
-        <p:txBody>
-          <a:bodyPr/>
-          <a:p/>
-        </p:txBody>
-      </p:sp>
-      <p:sp>
-        <p:nvSpPr>
-          <p:cNvPr id="9" name="Text 7"/>
-          <p:cNvSpPr/>
-          <p:nvPr/>
-        </p:nvSpPr>
-        <p:spPr>
-          <a:xfrm>
-            <a:off x="3368535" y="2046061"/>
-            <a:ext cx="1080478" cy="263073"/>
-          </a:xfrm>
-          <a:prstGeom prst="rect">
-            <a:avLst/>
-          </a:prstGeom>
-          <a:noFill/>
-          <a:ln/>
-        </p:spPr>
-        <p:txBody>
-          <a:bodyPr wrap="square" lIns="0" tIns="0" rIns="0" bIns="0" rtlCol="0" anchor="t"/>
-          <a:lstStyle/>
-          <a:p>
-            <a:pPr algn="ctr" indent="0" marL="0">
-              <a:buNone/>
-            </a:pPr>
-            <a:r>
-              <a:rPr lang="en-GB" altLang="en-US" sz="1644" b="1" dirty="0">
-                <a:solidFill>
-                  <a:srgbClr val="0C695A"/>
-                </a:solidFill>
-                <a:latin typeface="Segoe UI" pitchFamily="34" charset="0"/>
-                <a:ea typeface="Segoe UI" pitchFamily="34" charset="-122"/>
-                <a:cs typeface="Segoe UI" pitchFamily="34" charset="-120"/>
-              </a:rPr>
-              <a:t>schema.ts</a:t>
-            </a:r>
-            <a:endParaRPr lang="en-GB" sz="1644" dirty="0"/>
-          </a:p>
-        </p:txBody>
-      </p:sp>
-      <p:sp>
-        <p:nvSpPr>
-          <p:cNvPr id="10" name="Shape 8"/>
-          <p:cNvSpPr/>
-          <p:nvPr/>
-        </p:nvSpPr>
-        <p:spPr>
-          <a:xfrm>
-            <a:off x="4655713" y="2215180"/>
-            <a:ext cx="497959" cy="0"/>
-          </a:xfrm>
-          <a:prstGeom prst="line">
-            <a:avLst/>
-          </a:prstGeom>
-          <a:noFill/>
-          <a:ln w="23489">
-            <a:solidFill>
-              <a:srgbClr val="117865"/>
-            </a:solidFill>
-            <a:prstDash val="solid"/>
-            <a:tailEnd type="triangle"/>
-          </a:ln>
-        </p:spPr>
-        <p:txBody>
-          <a:bodyPr/>
-          <a:p/>
-        </p:txBody>
-      </p:sp>
-      <p:sp>
-        <p:nvSpPr>
-          <p:cNvPr id="11" name="Shape 9"/>
-          <p:cNvSpPr/>
-          <p:nvPr/>
-        </p:nvSpPr>
-        <p:spPr>
-          <a:xfrm>
-            <a:off x="5219441" y="1764198"/>
-            <a:ext cx="1277783" cy="892569"/>
-          </a:xfrm>
-          <a:prstGeom prst="roundRect">
-            <a:avLst>
-              <a:gd name="adj" fmla="val 8421"/>
-            </a:avLst>
-          </a:prstGeom>
-          <a:solidFill>
-            <a:srgbClr val="EFF6FC"/>
-          </a:solidFill>
-          <a:ln w="15240">
-            <a:solidFill>
-              <a:srgbClr val="0078D4"/>
-            </a:solidFill>
-            <a:prstDash val="solid"/>
-          </a:ln>
-        </p:spPr>
-        <p:txBody>
-          <a:bodyPr/>
-          <a:p/>
-        </p:txBody>
-      </p:sp>
-      <p:sp>
-        <p:nvSpPr>
-          <p:cNvPr id="12" name="Text 10"/>
-          <p:cNvSpPr/>
-          <p:nvPr/>
-        </p:nvSpPr>
-        <p:spPr>
-          <a:xfrm>
-            <a:off x="5369768" y="2046061"/>
-            <a:ext cx="977128" cy="263073"/>
-          </a:xfrm>
-          <a:prstGeom prst="rect">
-            <a:avLst/>
-          </a:prstGeom>
-          <a:noFill/>
-          <a:ln/>
-        </p:spPr>
-        <p:txBody>
-          <a:bodyPr wrap="square" lIns="0" tIns="0" rIns="0" bIns="0" rtlCol="0" anchor="t"/>
-          <a:lstStyle/>
-          <a:p>
-            <a:pPr algn="ctr" indent="0" marL="0">
-              <a:buNone/>
-            </a:pPr>
-            <a:r>
-              <a:rPr lang="en-GB" altLang="en-US" sz="1644" b="1" dirty="0">
-                <a:solidFill>
-                  <a:srgbClr val="0078D4"/>
-                </a:solidFill>
-                <a:latin typeface="Segoe UI" pitchFamily="34" charset="0"/>
-                <a:ea typeface="Segoe UI" pitchFamily="34" charset="-122"/>
-                <a:cs typeface="Segoe UI" pitchFamily="34" charset="-120"/>
-              </a:rPr>
-              <a:t>rayfin up</a:t>
-            </a:r>
-            <a:endParaRPr lang="en-GB" sz="1644" dirty="0"/>
-          </a:p>
-        </p:txBody>
-      </p:sp>
-      <p:sp>
-        <p:nvSpPr>
-          <p:cNvPr id="13" name="Shape 11"/>
-          <p:cNvSpPr/>
-          <p:nvPr/>
-        </p:nvSpPr>
-        <p:spPr>
-          <a:xfrm>
-            <a:off x="6732110" y="1595079"/>
-            <a:ext cx="1099269" cy="1230805"/>
-          </a:xfrm>
-          <a:prstGeom prst="roundRect">
-            <a:avLst>
-              <a:gd name="adj" fmla="val 6838"/>
-            </a:avLst>
-          </a:prstGeom>
-          <a:solidFill>
-            <a:srgbClr val="EFF6FC"/>
-          </a:solidFill>
-          <a:ln w="15240">
-            <a:solidFill>
-              <a:srgbClr val="0078D4"/>
-            </a:solidFill>
-            <a:prstDash val="solid"/>
-          </a:ln>
-        </p:spPr>
-        <p:txBody>
-          <a:bodyPr/>
-          <a:p/>
-        </p:txBody>
-      </p:sp>
-      <p:sp>
-        <p:nvSpPr>
-          <p:cNvPr id="14" name="Text 12"/>
-          <p:cNvSpPr/>
-          <p:nvPr/>
-        </p:nvSpPr>
-        <p:spPr>
-          <a:xfrm>
-            <a:off x="6826065" y="1698429"/>
-            <a:ext cx="911360" cy="1033501"/>
-          </a:xfrm>
-          <a:prstGeom prst="rect">
-            <a:avLst/>
-          </a:prstGeom>
-          <a:noFill/>
-          <a:ln/>
-        </p:spPr>
-        <p:txBody>
-          <a:bodyPr wrap="square" lIns="0" tIns="0" rIns="0" bIns="0" rtlCol="0" anchor="t"/>
-          <a:lstStyle/>
-          <a:p>
-            <a:pPr algn="ctr" indent="0" marL="0">
-              <a:buNone/>
-            </a:pPr>
-            <a:r>
-              <a:rPr lang="en-GB" altLang="en-US" sz="1161" b="1" dirty="0">
-                <a:solidFill>
-                  <a:srgbClr val="242424"/>
-                </a:solidFill>
-                <a:latin typeface="Segoe UI" pitchFamily="34" charset="0"/>
-                <a:ea typeface="Segoe UI" pitchFamily="34" charset="-122"/>
-                <a:cs typeface="Segoe UI" pitchFamily="34" charset="-120"/>
-              </a:rPr>
-              <a:t>Data API</a:t>
-            </a:r>
-            <a:endParaRPr lang="en-GB" sz="1161" dirty="0"/>
-          </a:p>
-          <a:p>
-            <a:pPr algn="ctr" indent="0" marL="0">
-              <a:buNone/>
-            </a:pPr>
-            <a:r>
-              <a:rPr lang="en-GB" altLang="en-US" sz="1161" b="1" dirty="0">
-                <a:solidFill>
-                  <a:srgbClr val="242424"/>
-                </a:solidFill>
-                <a:latin typeface="Segoe UI" pitchFamily="34" charset="0"/>
-                <a:ea typeface="Segoe UI" pitchFamily="34" charset="-122"/>
-                <a:cs typeface="Segoe UI" pitchFamily="34" charset="-120"/>
-              </a:rPr>
-              <a:t>Builder</a:t>
-            </a:r>
-            <a:endParaRPr lang="en-GB" sz="1161" dirty="0"/>
-          </a:p>
-          <a:p>
-            <a:pPr algn="ctr" indent="0" marL="0">
-              <a:buNone/>
-            </a:pPr>
-            <a:r>
-              <a:rPr lang="en-GB" altLang="en-US" sz="1161" b="1" dirty="0">
-                <a:solidFill>
-                  <a:srgbClr val="242424"/>
-                </a:solidFill>
-                <a:latin typeface="Segoe UI" pitchFamily="34" charset="0"/>
-                <a:ea typeface="Segoe UI" pitchFamily="34" charset="-122"/>
-                <a:cs typeface="Segoe UI" pitchFamily="34" charset="-120"/>
-              </a:rPr>
-              <a:t>+</a:t>
-            </a:r>
-            <a:endParaRPr lang="en-GB" sz="1161" dirty="0"/>
-          </a:p>
-          <a:p>
-            <a:pPr algn="ctr" indent="0" marL="0">
-              <a:buNone/>
-            </a:pPr>
-            <a:r>
-              <a:rPr lang="en-GB" altLang="en-US" sz="1161" b="1" dirty="0">
-                <a:solidFill>
-                  <a:srgbClr val="242424"/>
-                </a:solidFill>
-                <a:latin typeface="Segoe UI" pitchFamily="34" charset="0"/>
-                <a:ea typeface="Segoe UI" pitchFamily="34" charset="-122"/>
-                <a:cs typeface="Segoe UI" pitchFamily="34" charset="-120"/>
-              </a:rPr>
-              <a:t>Fabric SQL</a:t>
-            </a:r>
-            <a:endParaRPr lang="en-GB" sz="1161" dirty="0"/>
-          </a:p>
-        </p:txBody>
-      </p:sp>
-      <p:sp>
-        <p:nvSpPr>
-          <p:cNvPr id="15" name="Shape 13"/>
-          <p:cNvSpPr/>
-          <p:nvPr/>
-        </p:nvSpPr>
-        <p:spPr>
-          <a:xfrm>
-            <a:off x="6562992" y="2215180"/>
-            <a:ext cx="150327" cy="0"/>
-          </a:xfrm>
-          <a:prstGeom prst="line">
-            <a:avLst/>
-          </a:prstGeom>
-          <a:noFill/>
-          <a:ln w="23489">
-            <a:solidFill>
-              <a:srgbClr val="0078D4"/>
-            </a:solidFill>
-            <a:prstDash val="solid"/>
-            <a:tailEnd type="triangle"/>
-          </a:ln>
-        </p:spPr>
-        <p:txBody>
-          <a:bodyPr/>
-          <a:p/>
-        </p:txBody>
-      </p:sp>
-      <p:sp>
-        <p:nvSpPr>
-          <p:cNvPr id="16" name="Shape 14"/>
-          <p:cNvSpPr/>
-          <p:nvPr/>
-        </p:nvSpPr>
-        <p:spPr>
-          <a:xfrm>
-            <a:off x="3227603" y="3530544"/>
-            <a:ext cx="1747556" cy="1033501"/>
-          </a:xfrm>
-          <a:prstGeom prst="roundRect">
-            <a:avLst>
-              <a:gd name="adj" fmla="val 7273"/>
-            </a:avLst>
-          </a:prstGeom>
-          <a:solidFill>
-            <a:srgbClr val="E3F7EF"/>
-          </a:solidFill>
-          <a:ln w="15240">
-            <a:solidFill>
-              <a:srgbClr val="117865"/>
-            </a:solidFill>
-            <a:prstDash val="solid"/>
-          </a:ln>
-        </p:spPr>
-        <p:txBody>
-          <a:bodyPr/>
-          <a:p/>
-        </p:txBody>
-      </p:sp>
-      <p:sp>
-        <p:nvSpPr>
-          <p:cNvPr id="17" name="Text 15"/>
-          <p:cNvSpPr/>
-          <p:nvPr/>
-        </p:nvSpPr>
-        <p:spPr>
-          <a:xfrm>
-            <a:off x="3387326" y="3699662"/>
-            <a:ext cx="1428110" cy="704660"/>
-          </a:xfrm>
-          <a:prstGeom prst="rect">
-            <a:avLst/>
-          </a:prstGeom>
-          <a:noFill/>
-          <a:ln/>
-        </p:spPr>
-        <p:txBody>
-          <a:bodyPr wrap="square" lIns="0" tIns="0" rIns="0" bIns="0" rtlCol="0" anchor="t"/>
-          <a:lstStyle/>
-          <a:p>
-            <a:pPr algn="ctr" indent="0" marL="0">
-              <a:buNone/>
-            </a:pPr>
-            <a:r>
-              <a:rPr lang="en-GB" altLang="en-US" sz="1315" b="1" dirty="0">
-                <a:solidFill>
-                  <a:srgbClr val="0C695A"/>
-                </a:solidFill>
-                <a:latin typeface="Segoe UI" pitchFamily="34" charset="0"/>
-                <a:ea typeface="Segoe UI" pitchFamily="34" charset="-122"/>
-                <a:cs typeface="Segoe UI" pitchFamily="34" charset="-120"/>
-              </a:rPr>
-              <a:t>RayfinClient</a:t>
-            </a:r>
-            <a:endParaRPr lang="en-GB" sz="1315" dirty="0"/>
-          </a:p>
-          <a:p>
-            <a:pPr algn="ctr" indent="0" marL="0">
-              <a:buNone/>
-            </a:pPr>
-            <a:r>
-              <a:rPr lang="en-GB" altLang="en-US" sz="1315" b="1" dirty="0">
-                <a:solidFill>
-                  <a:srgbClr val="0C695A"/>
-                </a:solidFill>
-                <a:latin typeface="Segoe UI" pitchFamily="34" charset="0"/>
-                <a:ea typeface="Segoe UI" pitchFamily="34" charset="-122"/>
-                <a:cs typeface="Segoe UI" pitchFamily="34" charset="-120"/>
-              </a:rPr>
-              <a:t>typed GraphQL proxies</a:t>
-            </a:r>
-            <a:endParaRPr lang="en-GB" sz="1315" dirty="0"/>
-          </a:p>
-        </p:txBody>
-      </p:sp>
-      <p:sp>
-        <p:nvSpPr>
-          <p:cNvPr id="18" name="Shape 16"/>
-          <p:cNvSpPr/>
-          <p:nvPr/>
-        </p:nvSpPr>
-        <p:spPr>
-          <a:xfrm>
-            <a:off x="3913472" y="2722535"/>
-            <a:ext cx="0" cy="742241"/>
-          </a:xfrm>
-          <a:prstGeom prst="line">
-            <a:avLst/>
-          </a:prstGeom>
-          <a:noFill/>
-          <a:ln w="23489">
-            <a:solidFill>
-              <a:srgbClr val="117865"/>
-            </a:solidFill>
-            <a:prstDash val="solid"/>
-            <a:tailEnd type="triangle"/>
-          </a:ln>
-        </p:spPr>
-        <p:txBody>
-          <a:bodyPr/>
-          <a:p/>
-        </p:txBody>
-      </p:sp>
-      <p:sp>
-        <p:nvSpPr>
-          <p:cNvPr id="19" name="Shape 17"/>
-          <p:cNvSpPr/>
-          <p:nvPr/>
-        </p:nvSpPr>
-        <p:spPr>
-          <a:xfrm>
-            <a:off x="5031532" y="3981526"/>
-            <a:ext cx="1277783" cy="0"/>
-          </a:xfrm>
-          <a:prstGeom prst="line">
-            <a:avLst/>
-          </a:prstGeom>
-          <a:noFill/>
-          <a:ln w="23489">
-            <a:solidFill>
-              <a:srgbClr val="117865"/>
-            </a:solidFill>
-            <a:prstDash val="solid"/>
-          </a:ln>
-        </p:spPr>
-        <p:txBody>
-          <a:bodyPr/>
-          <a:p/>
-        </p:txBody>
-      </p:sp>
-      <p:sp>
-        <p:nvSpPr>
-          <p:cNvPr id="20" name="Shape 18"/>
-          <p:cNvSpPr/>
-          <p:nvPr/>
-        </p:nvSpPr>
-        <p:spPr>
-          <a:xfrm>
-            <a:off x="6309314" y="2778907"/>
-            <a:ext cx="0" cy="1202619"/>
-          </a:xfrm>
-          <a:prstGeom prst="line">
-            <a:avLst/>
-          </a:prstGeom>
-          <a:noFill/>
-          <a:ln w="23489">
-            <a:solidFill>
-              <a:srgbClr val="117865"/>
-            </a:solidFill>
-            <a:prstDash val="solid"/>
-          </a:ln>
-        </p:spPr>
-        <p:txBody>
-          <a:bodyPr/>
-          <a:p/>
-        </p:txBody>
-      </p:sp>
-      <p:sp>
-        <p:nvSpPr>
-          <p:cNvPr id="21" name="Shape 19"/>
-          <p:cNvSpPr/>
-          <p:nvPr/>
-        </p:nvSpPr>
-        <p:spPr>
-          <a:xfrm>
-            <a:off x="6309314" y="2778907"/>
-            <a:ext cx="404005" cy="0"/>
-          </a:xfrm>
-          <a:prstGeom prst="line">
-            <a:avLst/>
-          </a:prstGeom>
-          <a:noFill/>
-          <a:ln w="23489">
-            <a:solidFill>
-              <a:srgbClr val="117865"/>
-            </a:solidFill>
-            <a:prstDash val="solid"/>
-            <a:tailEnd type="triangle"/>
-          </a:ln>
-        </p:spPr>
-        <p:txBody>
-          <a:bodyPr/>
-          <a:p/>
-        </p:txBody>
-      </p:sp>
-      <p:sp>
-        <p:nvSpPr>
-          <p:cNvPr id="22" name="Text 20"/>
-          <p:cNvSpPr/>
-          <p:nvPr/>
-        </p:nvSpPr>
-        <p:spPr>
-          <a:xfrm>
-            <a:off x="8275320" y="1700784"/>
-            <a:ext cx="3246120" cy="3310128"/>
-          </a:xfrm>
-          <a:prstGeom prst="rect">
-            <a:avLst/>
-          </a:prstGeom>
-          <a:noFill/>
-          <a:ln/>
-        </p:spPr>
-        <p:txBody>
-          <a:bodyPr wrap="square" lIns="254" tIns="254" rIns="254" bIns="254" rtlCol="0" anchor="ctr"/>
-          <a:lstStyle/>
-          <a:p>
-            <a:pPr marL="243840" indent="-243840">
-              <a:buSzPct val="100000"/>
-              <a:buChar char="•"/>
-            </a:pPr>
-            <a:r>
-              <a:rPr lang="en-GB" altLang="en-US" sz="1600" dirty="0">
-                <a:solidFill>
-                  <a:srgbClr val="242424"/>
-                </a:solidFill>
-                <a:latin typeface="Segoe UI" pitchFamily="34" charset="0"/>
-                <a:ea typeface="Segoe UI" pitchFamily="34" charset="-122"/>
-                <a:cs typeface="Segoe UI" pitchFamily="34" charset="-120"/>
-              </a:rPr>
-              <a:t>Field decorators define SQL types, limits and optional values.</a:t>
-            </a:r>
-            <a:endParaRPr lang="en-GB" sz="1600" dirty="0"/>
-          </a:p>
-          <a:p>
-            <a:pPr marL="243840" indent="-243840">
-              <a:buSzPct val="100000"/>
-              <a:buChar char="•"/>
-            </a:pPr>
-            <a:r>
-              <a:rPr lang="en-GB" altLang="en-US" sz="1600" dirty="0">
-                <a:solidFill>
-                  <a:srgbClr val="242424"/>
-                </a:solidFill>
-                <a:latin typeface="Segoe UI" pitchFamily="34" charset="0"/>
-                <a:ea typeface="Segoe UI" pitchFamily="34" charset="-122"/>
-                <a:cs typeface="Segoe UI" pitchFamily="34" charset="-120"/>
-              </a:rPr>
-              <a:t>Authorization decorators generate read and write policies.</a:t>
-            </a:r>
-            <a:endParaRPr lang="en-GB" sz="1600" dirty="0"/>
-          </a:p>
-          <a:p>
-            <a:pPr marL="243840" indent="-243840">
-              <a:buSzPct val="100000"/>
-              <a:buChar char="•"/>
-            </a:pPr>
-            <a:r>
-              <a:rPr lang="en-GB" altLang="en-US" sz="1600" dirty="0">
-                <a:solidFill>
-                  <a:srgbClr val="242424"/>
-                </a:solidFill>
-                <a:latin typeface="Segoe UI" pitchFamily="34" charset="0"/>
-                <a:ea typeface="Segoe UI" pitchFamily="34" charset="-122"/>
-                <a:cs typeface="Segoe UI" pitchFamily="34" charset="-120"/>
-              </a:rPr>
-              <a:t>schema.ts registers the 15 entities used by RayfinClient.</a:t>
-            </a:r>
-            <a:endParaRPr lang="en-GB" sz="1600" dirty="0"/>
-          </a:p>
-        </p:txBody>
-      </p:sp>
-      <p:sp>
-        <p:nvSpPr>
-          <p:cNvPr id="23" name="Text 21"/>
-          <p:cNvSpPr/>
-          <p:nvPr/>
-        </p:nvSpPr>
-        <p:spPr>
-          <a:xfrm>
-            <a:off x="530352" y="6428232"/>
-            <a:ext cx="10149840" cy="182880"/>
-          </a:xfrm>
-          <a:prstGeom prst="rect">
-            <a:avLst/>
-          </a:prstGeom>
-          <a:noFill/>
-          <a:ln/>
-        </p:spPr>
-        <p:txBody>
-          <a:bodyPr wrap="square" lIns="0" tIns="0" rIns="0" bIns="0" rtlCol="0" anchor="t"/>
-          <a:lstStyle/>
-          <a:p>
-            <a:pPr algn="l" indent="0" marL="0">
-              <a:buNone/>
-            </a:pPr>
-            <a:r>
-              <a:rPr lang="en-GB" altLang="en-US" sz="1050" dirty="0">
-                <a:solidFill>
-                  <a:srgbClr val="616161"/>
-                </a:solidFill>
-                <a:latin typeface="Segoe UI" pitchFamily="34" charset="0"/>
-                <a:ea typeface="Segoe UI" pitchFamily="34" charset="-122"/>
-                <a:cs typeface="Segoe UI" pitchFamily="34" charset="-120"/>
-              </a:rPr>
-              <a:t>Source: eraser/05-rayfin-generation.eraser.txt · rayfin/data/schema.ts</a:t>
-            </a:r>
-            <a:endParaRPr lang="en-GB" sz="1050" dirty="0"/>
-          </a:p>
-        </p:txBody>
-      </p:sp>
-      <p:sp>
-        <p:nvSpPr>
-          <p:cNvPr id="24" name="Text 22"/>
-          <p:cNvSpPr/>
+                <a:latin typeface="Segoe UI"/>
+              </a:rPr>
+              <a:t>Source: rayfin/data/*.ts (15 classes)</a:t>
+            </a:r>
+          </a:p>
+        </p:txBody>
+      </p:sp>
+      <p:sp>
+        <p:nvSpPr>
+          <p:cNvPr id="8" name="TextBox 7"/>
+          <p:cNvSpPr txBox="1"/>
           <p:nvPr/>
         </p:nvSpPr>
         <p:spPr>
@@ -9282,27 +8822,23 @@
             <a:avLst/>
           </a:prstGeom>
           <a:noFill/>
-          <a:ln/>
-        </p:spPr>
-        <p:txBody>
-          <a:bodyPr wrap="square" lIns="0" tIns="0" rIns="0" bIns="0" rtlCol="0" anchor="t"/>
-          <a:lstStyle/>
-          <a:p>
-            <a:pPr algn="r" indent="0" marL="0">
-              <a:buNone/>
-            </a:pPr>
-            <a:r>
-              <a:rPr lang="en-GB" altLang="en-US" sz="1050" dirty="0">
+        </p:spPr>
+        <p:txBody>
+          <a:bodyPr wrap="none" lIns="0" rIns="0" tIns="0" bIns="0" anchor="t">
+            <a:spAutoFit/>
+          </a:bodyPr>
+          <a:lstStyle/>
+          <a:p>
+            <a:pPr algn="r"/>
+            <a:r>
+              <a:rPr sz="1050" b="0">
                 <a:solidFill>
                   <a:srgbClr val="616161"/>
                 </a:solidFill>
-                <a:latin typeface="Segoe UI" pitchFamily="34" charset="0"/>
-                <a:ea typeface="Segoe UI" pitchFamily="34" charset="-122"/>
-                <a:cs typeface="Segoe UI" pitchFamily="34" charset="-120"/>
-              </a:rPr>
-              <a:t>11</a:t>
-            </a:r>
-            <a:endParaRPr lang="en-GB" sz="1050" dirty="0"/>
+                <a:latin typeface="Segoe UI"/>
+              </a:rPr>
+              <a:t>8</a:t>
+            </a:r>
           </a:p>
         </p:txBody>
       </p:sp>

</xml_diff>